<commit_message>
fix: resolve turbopack crash, sandbox proxy issues, and add select carets
- use webpack in next dev to avoid turbopack crashes
- use NEXT_PUBLIC_API_URL so frontend bypasses Next proxy (fixes sandbox EPERM)
- add ChevronDown to RouteExplorer selects to indicate they are dropdowns
</commit_message>
<xml_diff>
--- a/docs/AeroDex-SIH2026-Idea.pptx
+++ b/docs/AeroDex-SIH2026-Idea.pptx
@@ -5,7 +5,7 @@
     <p:sldMasterId id="2147483648" r:id="rId1"/>
   </p:sldMasterIdLst>
   <p:notesMasterIdLst>
-    <p:notesMasterId r:id="rId8"/>
+    <p:notesMasterId r:id="rId9"/>
   </p:notesMasterIdLst>
   <p:sldIdLst>
     <p:sldId id="291" r:id="rId2"/>
@@ -261,7 +261,7 @@
             <a:fld id="{C4D5ADD5-2BBC-4A94-8F86-D9013941F742}" type="datetimeFigureOut">
               <a:rPr lang="en-US"/>
               <a:pPr/>
-              <a:t>8/31/26</a:t>
+              <a:t>6/2/2026</a:t>
             </a:fld>
             <a:endParaRPr lang="en-US"/>
           </a:p>
@@ -1534,7 +1534,7 @@
           <a:p>
             <a:fld id="{E60792E3-D524-454C-8AFD-A91972900BCB}" type="datetime1">
               <a:rPr lang="en-US" smtClean="0"/>
-              <a:t>8/31/26</a:t>
+              <a:t>6/2/2026</a:t>
             </a:fld>
             <a:endParaRPr lang="en-US"/>
           </a:p>
@@ -1716,7 +1716,7 @@
           <a:p>
             <a:fld id="{053C3A68-6922-42D3-8905-ECC2D82A3469}" type="datetime1">
               <a:rPr lang="en-US" smtClean="0"/>
-              <a:t>8/31/26</a:t>
+              <a:t>6/2/2026</a:t>
             </a:fld>
             <a:endParaRPr lang="en-US"/>
           </a:p>
@@ -1908,7 +1908,7 @@
           <a:p>
             <a:fld id="{CB69E9F4-7604-4950-A8B2-8ACDEDB1506E}" type="datetime1">
               <a:rPr lang="en-US" smtClean="0"/>
-              <a:t>8/31/26</a:t>
+              <a:t>6/2/2026</a:t>
             </a:fld>
             <a:endParaRPr lang="en-US"/>
           </a:p>
@@ -2090,7 +2090,7 @@
           <a:p>
             <a:fld id="{708B7524-32A2-4C20-A58C-BC3BAA1042FC}" type="datetime1">
               <a:rPr lang="en-US" smtClean="0"/>
-              <a:t>8/31/26</a:t>
+              <a:t>6/2/2026</a:t>
             </a:fld>
             <a:endParaRPr lang="en-US"/>
           </a:p>
@@ -2349,7 +2349,7 @@
           <a:p>
             <a:fld id="{1E994447-D6B2-43BB-A877-57F1A267B999}" type="datetime1">
               <a:rPr lang="en-US" smtClean="0"/>
-              <a:t>8/31/26</a:t>
+              <a:t>6/2/2026</a:t>
             </a:fld>
             <a:endParaRPr lang="en-US"/>
           </a:p>
@@ -2648,7 +2648,7 @@
           <a:p>
             <a:fld id="{68920E16-BD35-483C-AA6B-346FC7E46DEA}" type="datetime1">
               <a:rPr lang="en-US" smtClean="0"/>
-              <a:t>8/31/26</a:t>
+              <a:t>6/2/2026</a:t>
             </a:fld>
             <a:endParaRPr lang="en-US"/>
           </a:p>
@@ -3081,7 +3081,7 @@
           <a:p>
             <a:fld id="{2FEAC6F8-5103-4FC0-A69E-5C6AE6469DA8}" type="datetime1">
               <a:rPr lang="en-US" smtClean="0"/>
-              <a:t>8/31/26</a:t>
+              <a:t>6/2/2026</a:t>
             </a:fld>
             <a:endParaRPr lang="en-US"/>
           </a:p>
@@ -3212,7 +3212,7 @@
           <a:p>
             <a:fld id="{C60C6921-0627-4C8F-83D5-0CF936D2FFDD}" type="datetime1">
               <a:rPr lang="en-US" smtClean="0"/>
-              <a:t>8/31/26</a:t>
+              <a:t>6/2/2026</a:t>
             </a:fld>
             <a:endParaRPr lang="en-US"/>
           </a:p>
@@ -3321,7 +3321,7 @@
           <a:p>
             <a:fld id="{2FF08AD7-8103-40F8-983C-E2BA6BB9CBE0}" type="datetime1">
               <a:rPr lang="en-US" smtClean="0"/>
-              <a:t>8/31/26</a:t>
+              <a:t>6/2/2026</a:t>
             </a:fld>
             <a:endParaRPr lang="en-US"/>
           </a:p>
@@ -3610,7 +3610,7 @@
           <a:p>
             <a:fld id="{DF8C06B4-9380-4A4D-AF49-A3596E17DAF5}" type="datetime1">
               <a:rPr lang="en-US" smtClean="0"/>
-              <a:t>8/31/26</a:t>
+              <a:t>6/2/2026</a:t>
             </a:fld>
             <a:endParaRPr lang="en-US"/>
           </a:p>
@@ -3879,7 +3879,7 @@
           <a:p>
             <a:fld id="{EF7FDEF1-C582-4E22-9E77-D68326471F28}" type="datetime1">
               <a:rPr lang="en-US" smtClean="0"/>
-              <a:t>8/31/26</a:t>
+              <a:t>6/2/2026</a:t>
             </a:fld>
             <a:endParaRPr lang="en-US"/>
           </a:p>
@@ -4122,7 +4122,7 @@
           <a:p>
             <a:fld id="{780A9602-A9A9-453F-AEF1-37B5837E02CD}" type="datetime1">
               <a:rPr lang="en-US" smtClean="0"/>
-              <a:t>8/31/26</a:t>
+              <a:t>6/2/2026</a:t>
             </a:fld>
             <a:endParaRPr lang="en-US"/>
           </a:p>
@@ -4673,7 +4673,7 @@
                 <a16:creationId xmlns:a16="http://schemas.microsoft.com/office/drawing/2014/main" id="{3E443FD7-A66B-4AA0-872D-B088B9BC5F17}"/>
               </a:ext>
               <a:ext uri="{C183D7F6-B498-43B3-948B-1728B52AA6E4}">
-                <adec:decorative xmlns:adec="http://schemas.microsoft.com/office/drawing/2017/decorative" val="1"/>
+                <adec:decorative xmlns:adec="http://schemas.microsoft.com/office/drawing/2017/decorative" xmlns="" val="1"/>
               </a:ext>
             </a:extLst>
           </p:cNvPr>
@@ -4733,7 +4733,7 @@
                 <a16:creationId xmlns:a16="http://schemas.microsoft.com/office/drawing/2014/main" id="{C04BE0EF-3561-49B4-9A29-F283168A91C7}"/>
               </a:ext>
               <a:ext uri="{C183D7F6-B498-43B3-948B-1728B52AA6E4}">
-                <adec:decorative xmlns:adec="http://schemas.microsoft.com/office/drawing/2017/decorative" val="1"/>
+                <adec:decorative xmlns:adec="http://schemas.microsoft.com/office/drawing/2017/decorative" xmlns="" val="1"/>
               </a:ext>
             </a:extLst>
           </p:cNvPr>
@@ -5604,7 +5604,16 @@
                 </a:solidFill>
                 <a:latin typeface="Garamond" panose="02020404030301010803" pitchFamily="18" charset="0"/>
               </a:rPr>
-              <a:t>SMART INDIA HACKATHON 2026</a:t>
+              <a:t>SMART INDIA HACKATHON </a:t>
+            </a:r>
+            <a:r>
+              <a:rPr lang="en-US" sz="4000" b="1" dirty="0" smtClean="0">
+                <a:solidFill>
+                  <a:schemeClr val="tx2"/>
+                </a:solidFill>
+                <a:latin typeface="Garamond" panose="02020404030301010803" pitchFamily="18" charset="0"/>
+              </a:rPr>
+              <a:t>2026</a:t>
             </a:r>
             <a:endParaRPr lang="en-IN" sz="4000" b="1" dirty="0">
               <a:solidFill>
@@ -5640,6 +5649,9 @@
             <a:pPr marL="285750" indent="-285750" algn="l">
               <a:buFont typeface="Arial" panose="020B0604020202020204" pitchFamily="34" charset="0"/>
               <a:buChar char="•"/>
+              <a:spcBef>
+                <a:spcPts val="2000"/>
+              </a:spcBef>
             </a:pPr>
             <a:r>
               <a:rPr lang="en-US" sz="1500" b="1" dirty="0">
@@ -5660,6 +5672,9 @@
             <a:pPr marL="285750" indent="-285750" algn="l">
               <a:buFont typeface="Arial" panose="020B0604020202020204" pitchFamily="34" charset="0"/>
               <a:buChar char="•"/>
+              <a:spcBef>
+                <a:spcPts val="2000"/>
+              </a:spcBef>
             </a:pPr>
             <a:r>
               <a:rPr lang="en-US" sz="1500" b="1" dirty="0">
@@ -5669,7 +5684,7 @@
               <a:t>Problem Statement Title – </a:t>
             </a:r>
             <a:r>
-              <a:rPr lang="en-US" sz="1600" dirty="0">
+              <a:rPr lang="en-US" sz="1100" dirty="0">
                 <a:latin typeface="Arial" panose="020B0604020202020204" pitchFamily="34" charset="0"/>
                 <a:cs typeface="Arial" panose="020B0604020202020204" pitchFamily="34" charset="0"/>
               </a:rPr>
@@ -5680,6 +5695,9 @@
             <a:pPr marL="285750" indent="-285750" algn="l">
               <a:buFont typeface="Arial" panose="020B0604020202020204" pitchFamily="34" charset="0"/>
               <a:buChar char="•"/>
+              <a:spcBef>
+                <a:spcPts val="2000"/>
+              </a:spcBef>
             </a:pPr>
             <a:r>
               <a:rPr lang="en-US" sz="1500" b="1" dirty="0">
@@ -5700,6 +5718,9 @@
             <a:pPr marL="285750" indent="-285750" algn="l">
               <a:buFont typeface="Arial" panose="020B0604020202020204" pitchFamily="34" charset="0"/>
               <a:buChar char="•"/>
+              <a:spcBef>
+                <a:spcPts val="2000"/>
+              </a:spcBef>
             </a:pPr>
             <a:r>
               <a:rPr lang="en-US" sz="1500" b="1" dirty="0">
@@ -5720,6 +5741,9 @@
             <a:pPr marL="285750" indent="-285750" algn="l">
               <a:buFont typeface="Arial" panose="020B0604020202020204" pitchFamily="34" charset="0"/>
               <a:buChar char="•"/>
+              <a:spcBef>
+                <a:spcPts val="2000"/>
+              </a:spcBef>
             </a:pPr>
             <a:r>
               <a:rPr lang="en-US" sz="1500" b="1" dirty="0">
@@ -5740,18 +5764,24 @@
             <a:pPr marL="285750" indent="-285750" algn="l">
               <a:buFont typeface="Arial" panose="020B0604020202020204" pitchFamily="34" charset="0"/>
               <a:buChar char="•"/>
+              <a:spcBef>
+                <a:spcPts val="2000"/>
+              </a:spcBef>
             </a:pPr>
             <a:r>
               <a:rPr lang="en-US" sz="1500" b="1" dirty="0">
                 <a:latin typeface="Arial" panose="020B0604020202020204" pitchFamily="34" charset="0"/>
                 <a:cs typeface="Arial" panose="020B0604020202020204" pitchFamily="34" charset="0"/>
               </a:rPr>
-              <a:t>Team Name – Copilots</a:t>
-            </a:r>
-            <a:endParaRPr lang="en-US" sz="1500" dirty="0">
-              <a:latin typeface="Arial" panose="020B0604020202020204" pitchFamily="34" charset="0"/>
-              <a:cs typeface="Arial" panose="020B0604020202020204" pitchFamily="34" charset="0"/>
-            </a:endParaRPr>
+              <a:t>Team Name – </a:t>
+            </a:r>
+            <a:r>
+              <a:rPr lang="en-US" sz="1500" dirty="0">
+                <a:latin typeface="Arial" panose="020B0604020202020204" pitchFamily="34" charset="0"/>
+                <a:cs typeface="Arial" panose="020B0604020202020204" pitchFamily="34" charset="0"/>
+              </a:rPr>
+              <a:t>[TEAM NAME]</a:t>
+            </a:r>
           </a:p>
         </p:txBody>
       </p:sp>
@@ -5889,6 +5919,14 @@
           <a:lstStyle/>
           <a:p>
             <a:pPr eaLnBrk="1" hangingPunct="1"/>
+            <a:r>
+              <a:rPr lang="en-US" sz="2800" b="1" dirty="0">
+                <a:latin typeface="Times New Roman" panose="02020603050405020304" pitchFamily="18" charset="0"/>
+                <a:ea typeface="ＭＳ Ｐゴシック" pitchFamily="1" charset="-128"/>
+                <a:cs typeface="Times New Roman" panose="02020603050405020304" pitchFamily="18" charset="0"/>
+              </a:rPr>
+              <a:t/>
+            </a:r>
             <a:br>
               <a:rPr lang="en-US" sz="2800" b="1" dirty="0">
                 <a:latin typeface="Times New Roman" panose="02020603050405020304" pitchFamily="18" charset="0"/>
@@ -5918,7 +5956,7 @@
         <p:spPr bwMode="auto">
           <a:xfrm>
             <a:off x="457200" y="1298448"/>
-            <a:ext cx="11292840" cy="4956048"/>
+            <a:ext cx="11292840" cy="3703320"/>
           </a:xfrm>
           <a:prstGeom prst="rect">
             <a:avLst/>
@@ -5940,6 +5978,9 @@
             <a:pPr marL="285750" indent="-285750">
               <a:buFont typeface="Wingdings" panose="05000000000000000000" pitchFamily="2" charset="2"/>
               <a:buChar char="v"/>
+              <a:spcBef>
+                <a:spcPts val="900"/>
+              </a:spcBef>
             </a:pPr>
             <a:r>
               <a:rPr lang="en-US" sz="1650" b="1" u="sng" dirty="0">
@@ -5956,46 +5997,32 @@
             <a:pPr marL="285750" indent="-285750" algn="just">
               <a:buFont typeface="Arial" panose="020B0604020202020204" pitchFamily="34" charset="0"/>
               <a:buChar char="•"/>
+              <a:spcBef>
+                <a:spcPts val="500"/>
+              </a:spcBef>
             </a:pPr>
             <a:r>
               <a:rPr lang="en-US" sz="1400" b="1" dirty="0">
                 <a:latin typeface="Arial" panose="020B0604020202020204" pitchFamily="34" charset="0"/>
                 <a:cs typeface="Arial" panose="020B0604020202020204" pitchFamily="34" charset="0"/>
               </a:rPr>
-              <a:t>Panel: </a:t>
+              <a:t>Method: </a:t>
             </a:r>
             <a:r>
               <a:rPr lang="en-US" sz="1400" dirty="0">
                 <a:latin typeface="Arial" panose="020B0604020202020204" pitchFamily="34" charset="0"/>
                 <a:cs typeface="Arial" panose="020B0604020202020204" pitchFamily="34" charset="0"/>
               </a:rPr>
-              <a:t>60 domestic city pairs × 7 booking horizons (T-1 to T-60) × 3 fixed IST slots = 420 strata, ~1,155 observations a day.</a:t>
-            </a:r>
-          </a:p>
-          <a:p>
-            <a:pPr marL="285750" indent="-285750" algn="just">
-              <a:buFont typeface="Arial" panose="020B0604020202020204" pitchFamily="34" charset="0"/>
-              <a:buChar char="•"/>
-            </a:pPr>
-            <a:r>
-              <a:rPr lang="en-US" sz="1400" b="1" dirty="0">
-                <a:latin typeface="Arial" panose="020B0604020202020204" pitchFamily="34" charset="0"/>
-                <a:cs typeface="Arial" panose="020B0604020202020204" pitchFamily="34" charset="0"/>
-              </a:rPr>
-              <a:t>Method: </a:t>
-            </a:r>
-            <a:r>
-              <a:rPr lang="en-US" sz="1400" dirty="0">
-                <a:latin typeface="Arial" panose="020B0604020202020204" pitchFamily="34" charset="0"/>
-                <a:cs typeface="Arial" panose="020B0604020202020204" pitchFamily="34" charset="0"/>
-              </a:rPr>
-              <a:t>Jevons elementary index → hedonic quality adjustment on log fare → Lowe aggregation on DGCA passenger-traffic weights → chain-linked monthly, seasonally adjusted.</a:t>
+              <a:t>Jevons elementary index → hedonic quality adjustment on log fare → Lowe aggregation on DGCA passenger-traffic weights → chain-linked monthly.</a:t>
             </a:r>
           </a:p>
           <a:p>
             <a:pPr marL="285750" indent="-285750">
               <a:buFont typeface="Wingdings" panose="05000000000000000000" pitchFamily="2" charset="2"/>
               <a:buChar char="v"/>
+              <a:spcBef>
+                <a:spcPts val="900"/>
+              </a:spcBef>
             </a:pPr>
             <a:r>
               <a:rPr lang="en-US" sz="1650" b="1" u="sng" dirty="0">
@@ -6012,6 +6039,9 @@
             <a:pPr marL="285750" indent="-285750" algn="just">
               <a:buFont typeface="Arial" panose="020B0604020202020204" pitchFamily="34" charset="0"/>
               <a:buChar char="•"/>
+              <a:spcBef>
+                <a:spcPts val="500"/>
+              </a:spcBef>
             </a:pPr>
             <a:r>
               <a:rPr lang="en-US" sz="1400" dirty="0">
@@ -6025,6 +6055,9 @@
             <a:pPr marL="285750" indent="-285750" algn="just">
               <a:buFont typeface="Arial" panose="020B0604020202020204" pitchFamily="34" charset="0"/>
               <a:buChar char="•"/>
+              <a:spcBef>
+                <a:spcPts val="500"/>
+              </a:spcBef>
             </a:pPr>
             <a:r>
               <a:rPr lang="en-US" sz="1400" dirty="0">
@@ -6038,19 +6071,25 @@
             <a:pPr marL="285750" indent="-285750" algn="just">
               <a:buFont typeface="Arial" panose="020B0604020202020204" pitchFamily="34" charset="0"/>
               <a:buChar char="•"/>
+              <a:spcBef>
+                <a:spcPts val="500"/>
+              </a:spcBef>
             </a:pPr>
             <a:r>
               <a:rPr lang="en-US" sz="1400" dirty="0">
                 <a:latin typeface="Arial" panose="020B0604020202020204" pitchFamily="34" charset="0"/>
                 <a:cs typeface="Arial" panose="020B0604020202020204" pitchFamily="34" charset="0"/>
               </a:rPr>
-              <a:t>Coverage ratio and imputed weight share are published with every index point, so users can see how much of each number was actually observed.</a:t>
+              <a:t>Coverage ratio and imputed weight share are published with every index point.</a:t>
             </a:r>
           </a:p>
           <a:p>
             <a:pPr marL="285750" indent="-285750">
               <a:buFont typeface="Wingdings" panose="05000000000000000000" pitchFamily="2" charset="2"/>
               <a:buChar char="v"/>
+              <a:spcBef>
+                <a:spcPts val="900"/>
+              </a:spcBef>
             </a:pPr>
             <a:r>
               <a:rPr lang="en-US" sz="1650" b="1" u="sng" dirty="0">
@@ -6067,6 +6106,9 @@
             <a:pPr marL="285750" indent="-285750" algn="just">
               <a:buFont typeface="Arial" panose="020B0604020202020204" pitchFamily="34" charset="0"/>
               <a:buChar char="•"/>
+              <a:spcBef>
+                <a:spcPts val="500"/>
+              </a:spcBef>
             </a:pPr>
             <a:r>
               <a:rPr lang="en-US" sz="1400" b="1" dirty="0">
@@ -6080,13 +6122,16 @@
                 <a:latin typeface="Arial" panose="020B0604020202020204" pitchFamily="34" charset="0"/>
                 <a:cs typeface="Arial" panose="020B0604020202020204" pitchFamily="34" charset="0"/>
               </a:rPr>
-              <a:t>compute_index() is a pure function — no clock, no database, no network. Frozen panel in, frozen hash out; 11 golden tests assert bit-identical re-runs.</a:t>
+              <a:t>compute_index() is a pure function — no clock, no database, no network. 11 golden tests assert bit-identical re-runs.</a:t>
             </a:r>
           </a:p>
           <a:p>
             <a:pPr marL="285750" indent="-285750" algn="just">
               <a:buFont typeface="Arial" panose="020B0604020202020204" pitchFamily="34" charset="0"/>
               <a:buChar char="•"/>
+              <a:spcBef>
+                <a:spcPts val="500"/>
+              </a:spcBef>
             </a:pPr>
             <a:r>
               <a:rPr lang="en-US" sz="1400" b="1" dirty="0">
@@ -6107,26 +6152,16 @@
             <a:pPr marL="285750" indent="-285750" algn="just">
               <a:buFont typeface="Arial" panose="020B0604020202020204" pitchFamily="34" charset="0"/>
               <a:buChar char="•"/>
+              <a:spcBef>
+                <a:spcPts val="500"/>
+              </a:spcBef>
             </a:pPr>
             <a:r>
               <a:rPr lang="en-US" sz="1400" dirty="0">
                 <a:latin typeface="Arial" panose="020B0604020202020204" pitchFamily="34" charset="0"/>
                 <a:cs typeface="Arial" panose="020B0604020202020204" pitchFamily="34" charset="0"/>
               </a:rPr>
-              <a:t>the publisher refuses to release a run it cannot stand behind — refusal is code, not convention.</a:t>
-            </a:r>
-          </a:p>
-          <a:p>
-            <a:pPr marL="285750" indent="-285750" algn="just">
-              <a:buFont typeface="Arial" panose="020B0604020202020204" pitchFamily="34" charset="0"/>
-              <a:buChar char="•"/>
-            </a:pPr>
-            <a:r>
-              <a:rPr lang="en-US" sz="1400" dirty="0">
-                <a:latin typeface="Arial" panose="020B0604020202020204" pitchFamily="34" charset="0"/>
-                <a:cs typeface="Arial" panose="020B0604020202020204" pitchFamily="34" charset="0"/>
-              </a:rPr>
-              <a:t>₹0 recurring architecture on permanent free tiers — the system hands over to a ministry with no invoice and no vendor lock-in.</a:t>
+              <a:t>₹0 recurring on permanent free tiers, and the publisher refuses to release any run it cannot stand behind.</a:t>
             </a:r>
           </a:p>
         </p:txBody>
@@ -6187,13 +6222,18 @@
               <a:defRPr/>
             </a:pPr>
             <a:r>
-              <a:rPr lang="en-US" dirty="0">
+              <a:rPr lang="en-US">
                 <a:solidFill>
                   <a:schemeClr val="bg1"/>
                 </a:solidFill>
               </a:rPr>
-              <a:t>@SIH Idea submission</a:t>
-            </a:r>
+              <a:t>@SIH Idea submission- Template</a:t>
+            </a:r>
+            <a:endParaRPr lang="en-US" dirty="0">
+              <a:solidFill>
+                <a:schemeClr val="bg1"/>
+              </a:solidFill>
+            </a:endParaRPr>
           </a:p>
         </p:txBody>
       </p:sp>
@@ -6205,7 +6245,7 @@
                 <a16:creationId xmlns:a16="http://schemas.microsoft.com/office/drawing/2014/main" id="{5DBCE864-823D-4A13-9607-5DA1F0ED5FB8}"/>
               </a:ext>
               <a:ext uri="{C183D7F6-B498-43B3-948B-1728B52AA6E4}">
-                <adec:decorative xmlns:adec="http://schemas.microsoft.com/office/drawing/2017/decorative" val="0"/>
+                <adec:decorative xmlns:adec="http://schemas.microsoft.com/office/drawing/2017/decorative" xmlns="" val="0"/>
               </a:ext>
             </a:extLst>
           </p:cNvPr>
@@ -6241,10 +6281,10 @@
           <a:p>
             <a:pPr algn="ctr"/>
             <a:r>
-              <a:rPr lang="en-US" sz="1600" dirty="0"/>
-              <a:t>Copilots</a:t>
-            </a:r>
-            <a:endParaRPr lang="en-IN" sz="1600" dirty="0"/>
+              <a:rPr lang="en-US" sz="1000" dirty="0"/>
+              <a:t>[TEAM NAME]</a:t>
+            </a:r>
+            <a:endParaRPr lang="en-IN" dirty="0"/>
           </a:p>
         </p:txBody>
       </p:sp>
@@ -6278,6 +6318,438 @@
           </a:prstGeom>
         </p:spPr>
       </p:pic>
+      <p:sp>
+        <p:nvSpPr>
+          <p:cNvPr id="901" name="cell1"/>
+          <p:cNvSpPr/>
+          <p:nvPr/>
+        </p:nvSpPr>
+        <p:spPr>
+          <a:xfrm>
+            <a:off x="932688" y="5285232"/>
+            <a:ext cx="1755648" cy="731520"/>
+          </a:xfrm>
+          <a:prstGeom prst="roundRect">
+            <a:avLst>
+              <a:gd name="adj" fmla="val 14000"/>
+            </a:avLst>
+          </a:prstGeom>
+          <a:solidFill>
+            <a:srgbClr val="DCE6F1"/>
+          </a:solidFill>
+          <a:ln w="9525">
+            <a:solidFill>
+              <a:srgbClr val="4F81BD"/>
+            </a:solidFill>
+          </a:ln>
+        </p:spPr>
+        <p:txBody>
+          <a:bodyPr lIns="45720" rIns="45720" tIns="18000" bIns="18000" anchor="ctr" wrap="square">
+            <a:normAutofit/>
+          </a:bodyPr>
+          <a:lstStyle/>
+          <a:p>
+            <a:pPr algn="ctr"/>
+            <a:r>
+              <a:rPr lang="en-US" sz="1600" b="1" dirty="0">
+                <a:solidFill>
+                  <a:srgbClr val="1F497D"/>
+                </a:solidFill>
+                <a:latin typeface="Arial" panose="020B0604020202020204" pitchFamily="34" charset="0"/>
+                <a:cs typeface="Arial" panose="020B0604020202020204" pitchFamily="34" charset="0"/>
+              </a:rPr>
+              <a:t>60</a:t>
+            </a:r>
+          </a:p>
+          <a:p>
+            <a:pPr algn="ctr"/>
+            <a:r>
+              <a:rPr lang="en-US" sz="800" b="0" dirty="0">
+                <a:solidFill>
+                  <a:srgbClr val="1A1A1A"/>
+                </a:solidFill>
+                <a:latin typeface="Arial" panose="020B0604020202020204" pitchFamily="34" charset="0"/>
+                <a:cs typeface="Arial" panose="020B0604020202020204" pitchFamily="34" charset="0"/>
+              </a:rPr>
+              <a:t>routes</a:t>
+            </a:r>
+          </a:p>
+        </p:txBody>
+      </p:sp>
+      <p:sp>
+        <p:nvSpPr>
+          <p:cNvPr id="902" name="lbl902"/>
+          <p:cNvSpPr txBox="1"/>
+          <p:nvPr/>
+        </p:nvSpPr>
+        <p:spPr>
+          <a:xfrm>
+            <a:off x="2688336" y="5285232"/>
+            <a:ext cx="566928" cy="731520"/>
+          </a:xfrm>
+          <a:prstGeom prst="rect">
+            <a:avLst/>
+          </a:prstGeom>
+          <a:noFill/>
+        </p:spPr>
+        <p:txBody>
+          <a:bodyPr wrap="square" anchor="ctr">
+            <a:normAutofit/>
+          </a:bodyPr>
+          <a:lstStyle/>
+          <a:p>
+            <a:pPr algn="ctr"/>
+            <a:r>
+              <a:rPr lang="en-US" sz="1400" b="1" dirty="0">
+                <a:solidFill>
+                  <a:srgbClr val="4F81BD"/>
+                </a:solidFill>
+                <a:latin typeface="Arial" panose="020B0604020202020204" pitchFamily="34" charset="0"/>
+                <a:cs typeface="Arial" panose="020B0604020202020204" pitchFamily="34" charset="0"/>
+              </a:rPr>
+              <a:t>×</a:t>
+            </a:r>
+          </a:p>
+        </p:txBody>
+      </p:sp>
+      <p:sp>
+        <p:nvSpPr>
+          <p:cNvPr id="903" name="cell2"/>
+          <p:cNvSpPr/>
+          <p:nvPr/>
+        </p:nvSpPr>
+        <p:spPr>
+          <a:xfrm>
+            <a:off x="3255264" y="5285232"/>
+            <a:ext cx="1755648" cy="731520"/>
+          </a:xfrm>
+          <a:prstGeom prst="roundRect">
+            <a:avLst>
+              <a:gd name="adj" fmla="val 14000"/>
+            </a:avLst>
+          </a:prstGeom>
+          <a:solidFill>
+            <a:srgbClr val="DCE6F1"/>
+          </a:solidFill>
+          <a:ln w="9525">
+            <a:solidFill>
+              <a:srgbClr val="4F81BD"/>
+            </a:solidFill>
+          </a:ln>
+        </p:spPr>
+        <p:txBody>
+          <a:bodyPr lIns="45720" rIns="45720" tIns="18000" bIns="18000" anchor="ctr" wrap="square">
+            <a:normAutofit/>
+          </a:bodyPr>
+          <a:lstStyle/>
+          <a:p>
+            <a:pPr algn="ctr"/>
+            <a:r>
+              <a:rPr lang="en-US" sz="1600" b="1" dirty="0">
+                <a:solidFill>
+                  <a:srgbClr val="1F497D"/>
+                </a:solidFill>
+                <a:latin typeface="Arial" panose="020B0604020202020204" pitchFamily="34" charset="0"/>
+                <a:cs typeface="Arial" panose="020B0604020202020204" pitchFamily="34" charset="0"/>
+              </a:rPr>
+              <a:t>7</a:t>
+            </a:r>
+          </a:p>
+          <a:p>
+            <a:pPr algn="ctr"/>
+            <a:r>
+              <a:rPr lang="en-US" sz="800" b="0" dirty="0">
+                <a:solidFill>
+                  <a:srgbClr val="1A1A1A"/>
+                </a:solidFill>
+                <a:latin typeface="Arial" panose="020B0604020202020204" pitchFamily="34" charset="0"/>
+                <a:cs typeface="Arial" panose="020B0604020202020204" pitchFamily="34" charset="0"/>
+              </a:rPr>
+              <a:t>horizons</a:t>
+            </a:r>
+          </a:p>
+        </p:txBody>
+      </p:sp>
+      <p:sp>
+        <p:nvSpPr>
+          <p:cNvPr id="904" name="lbl904"/>
+          <p:cNvSpPr txBox="1"/>
+          <p:nvPr/>
+        </p:nvSpPr>
+        <p:spPr>
+          <a:xfrm>
+            <a:off x="5010912" y="5285232"/>
+            <a:ext cx="566928" cy="731520"/>
+          </a:xfrm>
+          <a:prstGeom prst="rect">
+            <a:avLst/>
+          </a:prstGeom>
+          <a:noFill/>
+        </p:spPr>
+        <p:txBody>
+          <a:bodyPr wrap="square" anchor="ctr">
+            <a:normAutofit/>
+          </a:bodyPr>
+          <a:lstStyle/>
+          <a:p>
+            <a:pPr algn="ctr"/>
+            <a:r>
+              <a:rPr lang="en-US" sz="1400" b="1" dirty="0">
+                <a:solidFill>
+                  <a:srgbClr val="4F81BD"/>
+                </a:solidFill>
+                <a:latin typeface="Arial" panose="020B0604020202020204" pitchFamily="34" charset="0"/>
+                <a:cs typeface="Arial" panose="020B0604020202020204" pitchFamily="34" charset="0"/>
+              </a:rPr>
+              <a:t>×</a:t>
+            </a:r>
+          </a:p>
+        </p:txBody>
+      </p:sp>
+      <p:sp>
+        <p:nvSpPr>
+          <p:cNvPr id="905" name="cell3"/>
+          <p:cNvSpPr/>
+          <p:nvPr/>
+        </p:nvSpPr>
+        <p:spPr>
+          <a:xfrm>
+            <a:off x="5577840" y="5285232"/>
+            <a:ext cx="1755648" cy="731520"/>
+          </a:xfrm>
+          <a:prstGeom prst="roundRect">
+            <a:avLst>
+              <a:gd name="adj" fmla="val 14000"/>
+            </a:avLst>
+          </a:prstGeom>
+          <a:solidFill>
+            <a:srgbClr val="DCE6F1"/>
+          </a:solidFill>
+          <a:ln w="9525">
+            <a:solidFill>
+              <a:srgbClr val="4F81BD"/>
+            </a:solidFill>
+          </a:ln>
+        </p:spPr>
+        <p:txBody>
+          <a:bodyPr lIns="45720" rIns="45720" tIns="18000" bIns="18000" anchor="ctr" wrap="square">
+            <a:normAutofit/>
+          </a:bodyPr>
+          <a:lstStyle/>
+          <a:p>
+            <a:pPr algn="ctr"/>
+            <a:r>
+              <a:rPr lang="en-US" sz="1600" b="1" dirty="0">
+                <a:solidFill>
+                  <a:srgbClr val="1F497D"/>
+                </a:solidFill>
+                <a:latin typeface="Arial" panose="020B0604020202020204" pitchFamily="34" charset="0"/>
+                <a:cs typeface="Arial" panose="020B0604020202020204" pitchFamily="34" charset="0"/>
+              </a:rPr>
+              <a:t>3</a:t>
+            </a:r>
+          </a:p>
+          <a:p>
+            <a:pPr algn="ctr"/>
+            <a:r>
+              <a:rPr lang="en-US" sz="800" b="0" dirty="0">
+                <a:solidFill>
+                  <a:srgbClr val="1A1A1A"/>
+                </a:solidFill>
+                <a:latin typeface="Arial" panose="020B0604020202020204" pitchFamily="34" charset="0"/>
+                <a:cs typeface="Arial" panose="020B0604020202020204" pitchFamily="34" charset="0"/>
+              </a:rPr>
+              <a:t>slots/day</a:t>
+            </a:r>
+          </a:p>
+        </p:txBody>
+      </p:sp>
+      <p:sp>
+        <p:nvSpPr>
+          <p:cNvPr id="906" name="lbl906"/>
+          <p:cNvSpPr txBox="1"/>
+          <p:nvPr/>
+        </p:nvSpPr>
+        <p:spPr>
+          <a:xfrm>
+            <a:off x="7333488" y="5285232"/>
+            <a:ext cx="566928" cy="731520"/>
+          </a:xfrm>
+          <a:prstGeom prst="rect">
+            <a:avLst/>
+          </a:prstGeom>
+          <a:noFill/>
+        </p:spPr>
+        <p:txBody>
+          <a:bodyPr wrap="square" anchor="ctr">
+            <a:normAutofit/>
+          </a:bodyPr>
+          <a:lstStyle/>
+          <a:p>
+            <a:pPr algn="ctr"/>
+            <a:r>
+              <a:rPr lang="en-US" sz="1400" b="1" dirty="0">
+                <a:solidFill>
+                  <a:srgbClr val="4F81BD"/>
+                </a:solidFill>
+                <a:latin typeface="Arial" panose="020B0604020202020204" pitchFamily="34" charset="0"/>
+                <a:cs typeface="Arial" panose="020B0604020202020204" pitchFamily="34" charset="0"/>
+              </a:rPr>
+              <a:t>=</a:t>
+            </a:r>
+          </a:p>
+        </p:txBody>
+      </p:sp>
+      <p:sp>
+        <p:nvSpPr>
+          <p:cNvPr id="907" name="cell4"/>
+          <p:cNvSpPr/>
+          <p:nvPr/>
+        </p:nvSpPr>
+        <p:spPr>
+          <a:xfrm>
+            <a:off x="7900416" y="5285232"/>
+            <a:ext cx="1755648" cy="731520"/>
+          </a:xfrm>
+          <a:prstGeom prst="roundRect">
+            <a:avLst>
+              <a:gd name="adj" fmla="val 14000"/>
+            </a:avLst>
+          </a:prstGeom>
+          <a:solidFill>
+            <a:srgbClr val="DCE6F1"/>
+          </a:solidFill>
+          <a:ln w="9525">
+            <a:solidFill>
+              <a:srgbClr val="4F81BD"/>
+            </a:solidFill>
+          </a:ln>
+        </p:spPr>
+        <p:txBody>
+          <a:bodyPr lIns="45720" rIns="45720" tIns="18000" bIns="18000" anchor="ctr" wrap="square">
+            <a:normAutofit/>
+          </a:bodyPr>
+          <a:lstStyle/>
+          <a:p>
+            <a:pPr algn="ctr"/>
+            <a:r>
+              <a:rPr lang="en-US" sz="1600" b="1" dirty="0">
+                <a:solidFill>
+                  <a:srgbClr val="1F497D"/>
+                </a:solidFill>
+                <a:latin typeface="Arial" panose="020B0604020202020204" pitchFamily="34" charset="0"/>
+                <a:cs typeface="Arial" panose="020B0604020202020204" pitchFamily="34" charset="0"/>
+              </a:rPr>
+              <a:t>420</a:t>
+            </a:r>
+          </a:p>
+          <a:p>
+            <a:pPr algn="ctr"/>
+            <a:r>
+              <a:rPr lang="en-US" sz="800" b="0" dirty="0">
+                <a:solidFill>
+                  <a:srgbClr val="1A1A1A"/>
+                </a:solidFill>
+                <a:latin typeface="Arial" panose="020B0604020202020204" pitchFamily="34" charset="0"/>
+                <a:cs typeface="Arial" panose="020B0604020202020204" pitchFamily="34" charset="0"/>
+              </a:rPr>
+              <a:t>strata</a:t>
+            </a:r>
+          </a:p>
+        </p:txBody>
+      </p:sp>
+      <p:sp>
+        <p:nvSpPr>
+          <p:cNvPr id="908" name="lbl908"/>
+          <p:cNvSpPr txBox="1"/>
+          <p:nvPr/>
+        </p:nvSpPr>
+        <p:spPr>
+          <a:xfrm>
+            <a:off x="9656064" y="5285232"/>
+            <a:ext cx="566928" cy="731520"/>
+          </a:xfrm>
+          <a:prstGeom prst="rect">
+            <a:avLst/>
+          </a:prstGeom>
+          <a:noFill/>
+        </p:spPr>
+        <p:txBody>
+          <a:bodyPr wrap="square" anchor="ctr">
+            <a:normAutofit/>
+          </a:bodyPr>
+          <a:lstStyle/>
+          <a:p>
+            <a:pPr algn="ctr"/>
+            <a:r>
+              <a:rPr lang="en-US" sz="1400" b="1" dirty="0">
+                <a:solidFill>
+                  <a:srgbClr val="4F81BD"/>
+                </a:solidFill>
+                <a:latin typeface="Arial" panose="020B0604020202020204" pitchFamily="34" charset="0"/>
+                <a:cs typeface="Arial" panose="020B0604020202020204" pitchFamily="34" charset="0"/>
+              </a:rPr>
+              <a:t>→</a:t>
+            </a:r>
+          </a:p>
+        </p:txBody>
+      </p:sp>
+      <p:sp>
+        <p:nvSpPr>
+          <p:cNvPr id="909" name="cell5"/>
+          <p:cNvSpPr/>
+          <p:nvPr/>
+        </p:nvSpPr>
+        <p:spPr>
+          <a:xfrm>
+            <a:off x="10222992" y="5285232"/>
+            <a:ext cx="1755648" cy="731520"/>
+          </a:xfrm>
+          <a:prstGeom prst="roundRect">
+            <a:avLst>
+              <a:gd name="adj" fmla="val 14000"/>
+            </a:avLst>
+          </a:prstGeom>
+          <a:solidFill>
+            <a:srgbClr val="1F497D"/>
+          </a:solidFill>
+          <a:ln>
+            <a:noFill/>
+          </a:ln>
+        </p:spPr>
+        <p:txBody>
+          <a:bodyPr lIns="45720" rIns="45720" tIns="18000" bIns="18000" anchor="ctr" wrap="square">
+            <a:normAutofit/>
+          </a:bodyPr>
+          <a:lstStyle/>
+          <a:p>
+            <a:pPr algn="ctr"/>
+            <a:r>
+              <a:rPr lang="en-US" sz="1600" b="1" dirty="0">
+                <a:solidFill>
+                  <a:srgbClr val="FFFFFF"/>
+                </a:solidFill>
+                <a:latin typeface="Arial" panose="020B0604020202020204" pitchFamily="34" charset="0"/>
+                <a:cs typeface="Arial" panose="020B0604020202020204" pitchFamily="34" charset="0"/>
+              </a:rPr>
+              <a:t>~1,155</a:t>
+            </a:r>
+          </a:p>
+          <a:p>
+            <a:pPr algn="ctr"/>
+            <a:r>
+              <a:rPr lang="en-US" sz="800" b="0" dirty="0">
+                <a:solidFill>
+                  <a:srgbClr val="D6E2F0"/>
+                </a:solidFill>
+                <a:latin typeface="Arial" panose="020B0604020202020204" pitchFamily="34" charset="0"/>
+                <a:cs typeface="Arial" panose="020B0604020202020204" pitchFamily="34" charset="0"/>
+              </a:rPr>
+              <a:t>observations/day</a:t>
+            </a:r>
+          </a:p>
+        </p:txBody>
+      </p:sp>
     </p:spTree>
   </p:cSld>
   <p:clrMapOvr>
@@ -6405,7 +6877,7 @@
         <p:spPr bwMode="auto">
           <a:xfrm>
             <a:off x="457200" y="1298448"/>
-            <a:ext cx="11292840" cy="4956048"/>
+            <a:ext cx="11292840" cy="3200400"/>
           </a:xfrm>
           <a:prstGeom prst="rect">
             <a:avLst/>
@@ -6427,6 +6899,9 @@
             <a:pPr marL="285750" indent="-285750">
               <a:buFont typeface="Wingdings" panose="05000000000000000000" pitchFamily="2" charset="2"/>
               <a:buChar char="v"/>
+              <a:spcBef>
+                <a:spcPts val="900"/>
+              </a:spcBef>
             </a:pPr>
             <a:r>
               <a:rPr lang="en-US" sz="1650" b="1" u="sng" dirty="0">
@@ -6443,6 +6918,9 @@
             <a:pPr marL="285750" indent="-285750" algn="just">
               <a:buFont typeface="Arial" panose="020B0604020202020204" pitchFamily="34" charset="0"/>
               <a:buChar char="•"/>
+              <a:spcBef>
+                <a:spcPts val="500"/>
+              </a:spcBef>
             </a:pPr>
             <a:r>
               <a:rPr lang="en-US" sz="1400" dirty="0">
@@ -6456,6 +6934,9 @@
             <a:pPr marL="285750" indent="-285750" algn="just">
               <a:buFont typeface="Arial" panose="020B0604020202020204" pitchFamily="34" charset="0"/>
               <a:buChar char="•"/>
+              <a:spcBef>
+                <a:spcPts val="500"/>
+              </a:spcBef>
             </a:pPr>
             <a:r>
               <a:rPr lang="en-US" sz="1400" dirty="0">
@@ -6469,6 +6950,9 @@
             <a:pPr marL="285750" indent="-285750" algn="just">
               <a:buFont typeface="Arial" panose="020B0604020202020204" pitchFamily="34" charset="0"/>
               <a:buChar char="•"/>
+              <a:spcBef>
+                <a:spcPts val="500"/>
+              </a:spcBef>
             </a:pPr>
             <a:r>
               <a:rPr lang="en-US" sz="1400" dirty="0">
@@ -6482,6 +6966,9 @@
             <a:pPr marL="285750" indent="-285750" algn="just">
               <a:buFont typeface="Arial" panose="020B0604020202020204" pitchFamily="34" charset="0"/>
               <a:buChar char="•"/>
+              <a:spcBef>
+                <a:spcPts val="500"/>
+              </a:spcBef>
             </a:pPr>
             <a:r>
               <a:rPr lang="en-US" sz="1400" dirty="0">
@@ -6495,6 +6982,9 @@
             <a:pPr marL="285750" indent="-285750">
               <a:buFont typeface="Wingdings" panose="05000000000000000000" pitchFamily="2" charset="2"/>
               <a:buChar char="v"/>
+              <a:spcBef>
+                <a:spcPts val="900"/>
+              </a:spcBef>
             </a:pPr>
             <a:r>
               <a:rPr lang="en-US" sz="1650" b="1" u="sng" dirty="0">
@@ -6511,91 +7001,25 @@
             <a:pPr marL="285750" indent="-285750" algn="just">
               <a:buFont typeface="Arial" panose="020B0604020202020204" pitchFamily="34" charset="0"/>
               <a:buChar char="•"/>
+              <a:spcBef>
+                <a:spcPts val="500"/>
+              </a:spcBef>
             </a:pPr>
             <a:r>
-              <a:rPr lang="en-US" sz="1400" b="1" dirty="0">
-                <a:latin typeface="Arial" panose="020B0604020202020204" pitchFamily="34" charset="0"/>
-                <a:cs typeface="Arial" panose="020B0604020202020204" pitchFamily="34" charset="0"/>
-              </a:rPr>
-              <a:t>Pipeline: </a:t>
-            </a:r>
-            <a:r>
               <a:rPr lang="en-US" sz="1400" dirty="0">
                 <a:latin typeface="Arial" panose="020B0604020202020204" pitchFamily="34" charset="0"/>
                 <a:cs typeface="Arial" panose="020B0604020202020204" pitchFamily="34" charset="0"/>
               </a:rPr>
-              <a:t>Scheduler → Acquire → Normalise → Validate → Store → Index → Publish</a:t>
-            </a:r>
-          </a:p>
-          <a:p>
-            <a:pPr marL="628650" indent="-285750" algn="just">
-              <a:buFont typeface="Arial" panose="020B0604020202020204" pitchFamily="34" charset="0"/>
-              <a:buChar char="–"/>
-            </a:pPr>
-            <a:r>
-              <a:rPr lang="en-US" sz="1300" dirty="0">
-                <a:latin typeface="Arial" panose="020B0604020202020204" pitchFamily="34" charset="0"/>
-                <a:cs typeface="Arial" panose="020B0604020202020204" pitchFamily="34" charset="0"/>
-              </a:rPr>
-              <a:t>Acquire — three-tier ladder: documented JSON endpoint, then internal XHR, then headless render. Cheapest tier first.</a:t>
-            </a:r>
-          </a:p>
-          <a:p>
-            <a:pPr marL="628650" indent="-285750" algn="just">
-              <a:buFont typeface="Arial" panose="020B0604020202020204" pitchFamily="34" charset="0"/>
-              <a:buChar char="–"/>
-            </a:pPr>
-            <a:r>
-              <a:rPr lang="en-US" sz="1300" dirty="0">
-                <a:latin typeface="Arial" panose="020B0604020202020204" pitchFamily="34" charset="0"/>
-                <a:cs typeface="Arial" panose="020B0604020202020204" pitchFamily="34" charset="0"/>
-              </a:rPr>
-              <a:t>Normalise — fare decomposition, dedup to the lowest all-inclusive fare per itinerary per slot, attribute tagging.</a:t>
-            </a:r>
-          </a:p>
-          <a:p>
-            <a:pPr marL="628650" indent="-285750" algn="just">
-              <a:buFont typeface="Arial" panose="020B0604020202020204" pitchFamily="34" charset="0"/>
-              <a:buChar char="–"/>
-            </a:pPr>
-            <a:r>
-              <a:rPr lang="en-US" sz="1300" dirty="0">
-                <a:latin typeface="Arial" panose="020B0604020202020204" pitchFamily="34" charset="0"/>
-                <a:cs typeface="Arial" panose="020B0604020202020204" pitchFamily="34" charset="0"/>
-              </a:rPr>
-              <a:t>Validate — plausibility bounds from config; failures are quarantined, never silently dropped.</a:t>
-            </a:r>
-          </a:p>
-          <a:p>
-            <a:pPr marL="628650" indent="-285750" algn="just">
-              <a:buFont typeface="Arial" panose="020B0604020202020204" pitchFamily="34" charset="0"/>
-              <a:buChar char="–"/>
-            </a:pPr>
-            <a:r>
-              <a:rPr lang="en-US" sz="1300" dirty="0">
-                <a:latin typeface="Arial" panose="020B0604020202020204" pitchFamily="34" charset="0"/>
-                <a:cs typeface="Arial" panose="020B0604020202020204" pitchFamily="34" charset="0"/>
-              </a:rPr>
-              <a:t>Store — quote_raw is append-only, enforced by database triggers on UPDATE, DELETE and TRUNCATE.</a:t>
-            </a:r>
-          </a:p>
-          <a:p>
-            <a:pPr marL="628650" indent="-285750" algn="just">
-              <a:buFont typeface="Arial" panose="020B0604020202020204" pitchFamily="34" charset="0"/>
-              <a:buChar char="–"/>
-            </a:pPr>
-            <a:r>
-              <a:rPr lang="en-US" sz="1300" dirty="0">
-                <a:latin typeface="Arial" panose="020B0604020202020204" pitchFamily="34" charset="0"/>
-                <a:cs typeface="Arial" panose="020B0604020202020204" pitchFamily="34" charset="0"/>
-              </a:rPr>
-              <a:t>Index — the pure function; Publish — static artifacts, with a refusal gate on unpublishable runs.</a:t>
+              <a:t>quote_raw is append-only, enforced by database triggers on UPDATE, DELETE and TRUNCATE; the index is a pure function of (panel, config).</a:t>
             </a:r>
           </a:p>
           <a:p>
             <a:pPr marL="285750" indent="-285750">
               <a:buFont typeface="Wingdings" panose="05000000000000000000" pitchFamily="2" charset="2"/>
               <a:buChar char="v"/>
+              <a:spcBef>
+                <a:spcPts val="900"/>
+              </a:spcBef>
             </a:pPr>
             <a:r>
               <a:rPr lang="en-US" sz="1650" b="1" u="sng" dirty="0">
@@ -6612,6 +7036,9 @@
             <a:pPr marL="285750" indent="-285750" algn="just">
               <a:buFont typeface="Arial" panose="020B0604020202020204" pitchFamily="34" charset="0"/>
               <a:buChar char="•"/>
+              <a:spcBef>
+                <a:spcPts val="500"/>
+              </a:spcBef>
             </a:pPr>
             <a:r>
               <a:rPr lang="en-US" sz="1400" dirty="0">
@@ -6625,6 +7052,9 @@
             <a:pPr marL="285750" indent="-285750" algn="just">
               <a:buFont typeface="Arial" panose="020B0604020202020204" pitchFamily="34" charset="0"/>
               <a:buChar char="•"/>
+              <a:spcBef>
+                <a:spcPts val="500"/>
+              </a:spcBef>
             </a:pPr>
             <a:r>
               <a:rPr lang="en-US" sz="1400" dirty="0">
@@ -6692,13 +7122,18 @@
               <a:defRPr/>
             </a:pPr>
             <a:r>
-              <a:rPr lang="en-US" dirty="0">
+              <a:rPr lang="en-US">
                 <a:solidFill>
                   <a:schemeClr val="bg1"/>
                 </a:solidFill>
               </a:rPr>
-              <a:t>@SIH Idea submission</a:t>
-            </a:r>
+              <a:t>@SIH Idea submission- Template</a:t>
+            </a:r>
+            <a:endParaRPr lang="en-US" dirty="0">
+              <a:solidFill>
+                <a:schemeClr val="bg1"/>
+              </a:solidFill>
+            </a:endParaRPr>
           </a:p>
         </p:txBody>
       </p:sp>
@@ -6710,7 +7145,7 @@
                 <a16:creationId xmlns:a16="http://schemas.microsoft.com/office/drawing/2014/main" id="{5DBCE864-823D-4A13-9607-5DA1F0ED5FB8}"/>
               </a:ext>
               <a:ext uri="{C183D7F6-B498-43B3-948B-1728B52AA6E4}">
-                <adec:decorative xmlns:adec="http://schemas.microsoft.com/office/drawing/2017/decorative" val="0"/>
+                <adec:decorative xmlns:adec="http://schemas.microsoft.com/office/drawing/2017/decorative" xmlns="" val="0"/>
               </a:ext>
             </a:extLst>
           </p:cNvPr>
@@ -6746,9 +7181,10 @@
           <a:p>
             <a:pPr algn="ctr"/>
             <a:r>
-              <a:rPr lang="en-IN" sz="1600" dirty="0"/>
-              <a:t>Copilots</a:t>
-            </a:r>
+              <a:rPr lang="en-US" sz="1000" dirty="0"/>
+              <a:t>[TEAM NAME]</a:t>
+            </a:r>
+            <a:endParaRPr lang="en-IN" dirty="0"/>
           </a:p>
         </p:txBody>
       </p:sp>
@@ -6782,6 +7218,434 @@
           </a:prstGeom>
         </p:spPr>
       </p:pic>
+      <p:sp>
+        <p:nvSpPr>
+          <p:cNvPr id="910" name="stage1"/>
+          <p:cNvSpPr/>
+          <p:nvPr/>
+        </p:nvSpPr>
+        <p:spPr>
+          <a:xfrm>
+            <a:off x="475488" y="4882896"/>
+            <a:ext cx="1773936" cy="713232"/>
+          </a:xfrm>
+          <a:prstGeom prst="chevron">
+            <a:avLst>
+              <a:gd name="adj" fmla="val 26000"/>
+            </a:avLst>
+          </a:prstGeom>
+          <a:solidFill>
+            <a:srgbClr val="4F81BD"/>
+          </a:solidFill>
+          <a:ln>
+            <a:noFill/>
+          </a:ln>
+        </p:spPr>
+        <p:txBody>
+          <a:bodyPr lIns="274320" rIns="274320" tIns="18000" bIns="18000" anchor="ctr" wrap="square">
+            <a:normAutofit/>
+          </a:bodyPr>
+          <a:lstStyle/>
+          <a:p>
+            <a:pPr algn="ctr"/>
+            <a:r>
+              <a:rPr lang="en-US" sz="950" b="1" dirty="0">
+                <a:solidFill>
+                  <a:srgbClr val="FFFFFF"/>
+                </a:solidFill>
+                <a:latin typeface="Arial" panose="020B0604020202020204" pitchFamily="34" charset="0"/>
+                <a:cs typeface="Arial" panose="020B0604020202020204" pitchFamily="34" charset="0"/>
+              </a:rPr>
+              <a:t>Scheduler</a:t>
+            </a:r>
+          </a:p>
+          <a:p>
+            <a:pPr algn="ctr"/>
+            <a:r>
+              <a:rPr lang="en-US" sz="700" b="0" dirty="0">
+                <a:solidFill>
+                  <a:srgbClr val="FFFFFF"/>
+                </a:solidFill>
+                <a:latin typeface="Arial" panose="020B0604020202020204" pitchFamily="34" charset="0"/>
+                <a:cs typeface="Arial" panose="020B0604020202020204" pitchFamily="34" charset="0"/>
+              </a:rPr>
+              <a:t>systemd timers</a:t>
+            </a:r>
+          </a:p>
+        </p:txBody>
+      </p:sp>
+      <p:sp>
+        <p:nvSpPr>
+          <p:cNvPr id="911" name="stage2"/>
+          <p:cNvSpPr/>
+          <p:nvPr/>
+        </p:nvSpPr>
+        <p:spPr>
+          <a:xfrm>
+            <a:off x="2057400" y="4882896"/>
+            <a:ext cx="1773936" cy="713232"/>
+          </a:xfrm>
+          <a:prstGeom prst="chevron">
+            <a:avLst>
+              <a:gd name="adj" fmla="val 26000"/>
+            </a:avLst>
+          </a:prstGeom>
+          <a:solidFill>
+            <a:srgbClr val="F79646"/>
+          </a:solidFill>
+          <a:ln>
+            <a:noFill/>
+          </a:ln>
+        </p:spPr>
+        <p:txBody>
+          <a:bodyPr lIns="274320" rIns="274320" tIns="18000" bIns="18000" anchor="ctr" wrap="square">
+            <a:normAutofit/>
+          </a:bodyPr>
+          <a:lstStyle/>
+          <a:p>
+            <a:pPr algn="ctr"/>
+            <a:r>
+              <a:rPr lang="en-US" sz="950" b="1" dirty="0">
+                <a:solidFill>
+                  <a:srgbClr val="FFFFFF"/>
+                </a:solidFill>
+                <a:latin typeface="Arial" panose="020B0604020202020204" pitchFamily="34" charset="0"/>
+                <a:cs typeface="Arial" panose="020B0604020202020204" pitchFamily="34" charset="0"/>
+              </a:rPr>
+              <a:t>Acquire</a:t>
+            </a:r>
+          </a:p>
+          <a:p>
+            <a:pPr algn="ctr"/>
+            <a:r>
+              <a:rPr lang="en-US" sz="700" b="0" dirty="0">
+                <a:solidFill>
+                  <a:srgbClr val="FFFFFF"/>
+                </a:solidFill>
+                <a:latin typeface="Arial" panose="020B0604020202020204" pitchFamily="34" charset="0"/>
+                <a:cs typeface="Arial" panose="020B0604020202020204" pitchFamily="34" charset="0"/>
+              </a:rPr>
+              <a:t>3-tier ladder</a:t>
+            </a:r>
+          </a:p>
+        </p:txBody>
+      </p:sp>
+      <p:sp>
+        <p:nvSpPr>
+          <p:cNvPr id="912" name="stage3"/>
+          <p:cNvSpPr/>
+          <p:nvPr/>
+        </p:nvSpPr>
+        <p:spPr>
+          <a:xfrm>
+            <a:off x="3639312" y="4882896"/>
+            <a:ext cx="1773936" cy="713232"/>
+          </a:xfrm>
+          <a:prstGeom prst="chevron">
+            <a:avLst>
+              <a:gd name="adj" fmla="val 26000"/>
+            </a:avLst>
+          </a:prstGeom>
+          <a:solidFill>
+            <a:srgbClr val="4F81BD"/>
+          </a:solidFill>
+          <a:ln>
+            <a:noFill/>
+          </a:ln>
+        </p:spPr>
+        <p:txBody>
+          <a:bodyPr lIns="274320" rIns="274320" tIns="18000" bIns="18000" anchor="ctr" wrap="square">
+            <a:normAutofit/>
+          </a:bodyPr>
+          <a:lstStyle/>
+          <a:p>
+            <a:pPr algn="ctr"/>
+            <a:r>
+              <a:rPr lang="en-US" sz="950" b="1" dirty="0">
+                <a:solidFill>
+                  <a:srgbClr val="FFFFFF"/>
+                </a:solidFill>
+                <a:latin typeface="Arial" panose="020B0604020202020204" pitchFamily="34" charset="0"/>
+                <a:cs typeface="Arial" panose="020B0604020202020204" pitchFamily="34" charset="0"/>
+              </a:rPr>
+              <a:t>Normalise</a:t>
+            </a:r>
+          </a:p>
+          <a:p>
+            <a:pPr algn="ctr"/>
+            <a:r>
+              <a:rPr lang="en-US" sz="700" b="0" dirty="0">
+                <a:solidFill>
+                  <a:srgbClr val="FFFFFF"/>
+                </a:solidFill>
+                <a:latin typeface="Arial" panose="020B0604020202020204" pitchFamily="34" charset="0"/>
+                <a:cs typeface="Arial" panose="020B0604020202020204" pitchFamily="34" charset="0"/>
+              </a:rPr>
+              <a:t>dedup + tag</a:t>
+            </a:r>
+          </a:p>
+        </p:txBody>
+      </p:sp>
+      <p:sp>
+        <p:nvSpPr>
+          <p:cNvPr id="913" name="stage4"/>
+          <p:cNvSpPr/>
+          <p:nvPr/>
+        </p:nvSpPr>
+        <p:spPr>
+          <a:xfrm>
+            <a:off x="5221223" y="4882896"/>
+            <a:ext cx="1773936" cy="713232"/>
+          </a:xfrm>
+          <a:prstGeom prst="chevron">
+            <a:avLst>
+              <a:gd name="adj" fmla="val 26000"/>
+            </a:avLst>
+          </a:prstGeom>
+          <a:solidFill>
+            <a:srgbClr val="4F81BD"/>
+          </a:solidFill>
+          <a:ln>
+            <a:noFill/>
+          </a:ln>
+        </p:spPr>
+        <p:txBody>
+          <a:bodyPr lIns="274320" rIns="274320" tIns="18000" bIns="18000" anchor="ctr" wrap="square">
+            <a:normAutofit/>
+          </a:bodyPr>
+          <a:lstStyle/>
+          <a:p>
+            <a:pPr algn="ctr"/>
+            <a:r>
+              <a:rPr lang="en-US" sz="950" b="1" dirty="0">
+                <a:solidFill>
+                  <a:srgbClr val="FFFFFF"/>
+                </a:solidFill>
+                <a:latin typeface="Arial" panose="020B0604020202020204" pitchFamily="34" charset="0"/>
+                <a:cs typeface="Arial" panose="020B0604020202020204" pitchFamily="34" charset="0"/>
+              </a:rPr>
+              <a:t>Validate</a:t>
+            </a:r>
+          </a:p>
+          <a:p>
+            <a:pPr algn="ctr"/>
+            <a:r>
+              <a:rPr lang="en-US" sz="700" b="0" dirty="0">
+                <a:solidFill>
+                  <a:srgbClr val="FFFFFF"/>
+                </a:solidFill>
+                <a:latin typeface="Arial" panose="020B0604020202020204" pitchFamily="34" charset="0"/>
+                <a:cs typeface="Arial" panose="020B0604020202020204" pitchFamily="34" charset="0"/>
+              </a:rPr>
+              <a:t>quarantine</a:t>
+            </a:r>
+          </a:p>
+        </p:txBody>
+      </p:sp>
+      <p:sp>
+        <p:nvSpPr>
+          <p:cNvPr id="914" name="stage5"/>
+          <p:cNvSpPr/>
+          <p:nvPr/>
+        </p:nvSpPr>
+        <p:spPr>
+          <a:xfrm>
+            <a:off x="6803136" y="4882896"/>
+            <a:ext cx="1773936" cy="713232"/>
+          </a:xfrm>
+          <a:prstGeom prst="chevron">
+            <a:avLst>
+              <a:gd name="adj" fmla="val 26000"/>
+            </a:avLst>
+          </a:prstGeom>
+          <a:solidFill>
+            <a:srgbClr val="4F81BD"/>
+          </a:solidFill>
+          <a:ln>
+            <a:noFill/>
+          </a:ln>
+        </p:spPr>
+        <p:txBody>
+          <a:bodyPr lIns="274320" rIns="274320" tIns="18000" bIns="18000" anchor="ctr" wrap="square">
+            <a:normAutofit/>
+          </a:bodyPr>
+          <a:lstStyle/>
+          <a:p>
+            <a:pPr algn="ctr"/>
+            <a:r>
+              <a:rPr lang="en-US" sz="950" b="1" dirty="0">
+                <a:solidFill>
+                  <a:srgbClr val="FFFFFF"/>
+                </a:solidFill>
+                <a:latin typeface="Arial" panose="020B0604020202020204" pitchFamily="34" charset="0"/>
+                <a:cs typeface="Arial" panose="020B0604020202020204" pitchFamily="34" charset="0"/>
+              </a:rPr>
+              <a:t>Store</a:t>
+            </a:r>
+          </a:p>
+          <a:p>
+            <a:pPr algn="ctr"/>
+            <a:r>
+              <a:rPr lang="en-US" sz="700" b="0" dirty="0">
+                <a:solidFill>
+                  <a:srgbClr val="FFFFFF"/>
+                </a:solidFill>
+                <a:latin typeface="Arial" panose="020B0604020202020204" pitchFamily="34" charset="0"/>
+                <a:cs typeface="Arial" panose="020B0604020202020204" pitchFamily="34" charset="0"/>
+              </a:rPr>
+              <a:t>append-only</a:t>
+            </a:r>
+          </a:p>
+        </p:txBody>
+      </p:sp>
+      <p:sp>
+        <p:nvSpPr>
+          <p:cNvPr id="915" name="stage6"/>
+          <p:cNvSpPr/>
+          <p:nvPr/>
+        </p:nvSpPr>
+        <p:spPr>
+          <a:xfrm>
+            <a:off x="8385048" y="4882896"/>
+            <a:ext cx="1773936" cy="713232"/>
+          </a:xfrm>
+          <a:prstGeom prst="chevron">
+            <a:avLst>
+              <a:gd name="adj" fmla="val 26000"/>
+            </a:avLst>
+          </a:prstGeom>
+          <a:solidFill>
+            <a:srgbClr val="4F81BD"/>
+          </a:solidFill>
+          <a:ln>
+            <a:noFill/>
+          </a:ln>
+        </p:spPr>
+        <p:txBody>
+          <a:bodyPr lIns="274320" rIns="274320" tIns="18000" bIns="18000" anchor="ctr" wrap="square">
+            <a:normAutofit/>
+          </a:bodyPr>
+          <a:lstStyle/>
+          <a:p>
+            <a:pPr algn="ctr"/>
+            <a:r>
+              <a:rPr lang="en-US" sz="950" b="1" dirty="0">
+                <a:solidFill>
+                  <a:srgbClr val="FFFFFF"/>
+                </a:solidFill>
+                <a:latin typeface="Arial" panose="020B0604020202020204" pitchFamily="34" charset="0"/>
+                <a:cs typeface="Arial" panose="020B0604020202020204" pitchFamily="34" charset="0"/>
+              </a:rPr>
+              <a:t>Index</a:t>
+            </a:r>
+          </a:p>
+          <a:p>
+            <a:pPr algn="ctr"/>
+            <a:r>
+              <a:rPr lang="en-US" sz="700" b="0" dirty="0">
+                <a:solidFill>
+                  <a:srgbClr val="FFFFFF"/>
+                </a:solidFill>
+                <a:latin typeface="Arial" panose="020B0604020202020204" pitchFamily="34" charset="0"/>
+                <a:cs typeface="Arial" panose="020B0604020202020204" pitchFamily="34" charset="0"/>
+              </a:rPr>
+              <a:t>pure function</a:t>
+            </a:r>
+          </a:p>
+        </p:txBody>
+      </p:sp>
+      <p:sp>
+        <p:nvSpPr>
+          <p:cNvPr id="916" name="stage7"/>
+          <p:cNvSpPr/>
+          <p:nvPr/>
+        </p:nvSpPr>
+        <p:spPr>
+          <a:xfrm>
+            <a:off x="9966959" y="4882896"/>
+            <a:ext cx="1773936" cy="713232"/>
+          </a:xfrm>
+          <a:prstGeom prst="chevron">
+            <a:avLst>
+              <a:gd name="adj" fmla="val 26000"/>
+            </a:avLst>
+          </a:prstGeom>
+          <a:solidFill>
+            <a:srgbClr val="1F497D"/>
+          </a:solidFill>
+          <a:ln>
+            <a:noFill/>
+          </a:ln>
+        </p:spPr>
+        <p:txBody>
+          <a:bodyPr lIns="274320" rIns="274320" tIns="18000" bIns="18000" anchor="ctr" wrap="square">
+            <a:normAutofit/>
+          </a:bodyPr>
+          <a:lstStyle/>
+          <a:p>
+            <a:pPr algn="ctr"/>
+            <a:r>
+              <a:rPr lang="en-US" sz="950" b="1" dirty="0">
+                <a:solidFill>
+                  <a:srgbClr val="FFFFFF"/>
+                </a:solidFill>
+                <a:latin typeface="Arial" panose="020B0604020202020204" pitchFamily="34" charset="0"/>
+                <a:cs typeface="Arial" panose="020B0604020202020204" pitchFamily="34" charset="0"/>
+              </a:rPr>
+              <a:t>Publish</a:t>
+            </a:r>
+          </a:p>
+          <a:p>
+            <a:pPr algn="ctr"/>
+            <a:r>
+              <a:rPr lang="en-US" sz="700" b="0" dirty="0">
+                <a:solidFill>
+                  <a:srgbClr val="FFFFFF"/>
+                </a:solidFill>
+                <a:latin typeface="Arial" panose="020B0604020202020204" pitchFamily="34" charset="0"/>
+                <a:cs typeface="Arial" panose="020B0604020202020204" pitchFamily="34" charset="0"/>
+              </a:rPr>
+              <a:t>refusal gate</a:t>
+            </a:r>
+          </a:p>
+        </p:txBody>
+      </p:sp>
+      <p:sp>
+        <p:nvSpPr>
+          <p:cNvPr id="917" name="lbl917"/>
+          <p:cNvSpPr txBox="1"/>
+          <p:nvPr/>
+        </p:nvSpPr>
+        <p:spPr>
+          <a:xfrm>
+            <a:off x="475488" y="5650992"/>
+            <a:ext cx="11201400" cy="384048"/>
+          </a:xfrm>
+          <a:prstGeom prst="rect">
+            <a:avLst/>
+          </a:prstGeom>
+          <a:noFill/>
+        </p:spPr>
+        <p:txBody>
+          <a:bodyPr wrap="square" anchor="t">
+            <a:normAutofit/>
+          </a:bodyPr>
+          <a:lstStyle/>
+          <a:p>
+            <a:pPr algn="ctr"/>
+            <a:r>
+              <a:rPr lang="en-US" sz="900" b="0" dirty="0">
+                <a:solidFill>
+                  <a:srgbClr val="1A1A1A"/>
+                </a:solidFill>
+                <a:latin typeface="Arial" panose="020B0604020202020204" pitchFamily="34" charset="0"/>
+                <a:cs typeface="Arial" panose="020B0604020202020204" pitchFamily="34" charset="0"/>
+              </a:rPr>
+              <a:t>Six stages are complete and test-covered.  Acquire holds a deterministic fixture until a permitted source is secured — and Publish then refuses any index built on it.</a:t>
+            </a:r>
+          </a:p>
+        </p:txBody>
+      </p:sp>
     </p:spTree>
   </p:cSld>
   <p:clrMapOvr>
@@ -6924,7 +7788,7 @@
         <p:spPr bwMode="auto">
           <a:xfrm>
             <a:off x="457200" y="1298448"/>
-            <a:ext cx="11292840" cy="4956048"/>
+            <a:ext cx="11292840" cy="3310128"/>
           </a:xfrm>
           <a:prstGeom prst="rect">
             <a:avLst/>
@@ -6946,6 +7810,9 @@
             <a:pPr marL="285750" indent="-285750">
               <a:buFont typeface="Wingdings" panose="05000000000000000000" pitchFamily="2" charset="2"/>
               <a:buChar char="v"/>
+              <a:spcBef>
+                <a:spcPts val="900"/>
+              </a:spcBef>
             </a:pPr>
             <a:r>
               <a:rPr lang="en-US" sz="1650" b="1" u="sng" dirty="0">
@@ -6962,6 +7829,9 @@
             <a:pPr marL="285750" indent="-285750" algn="just">
               <a:buFont typeface="Arial" panose="020B0604020202020204" pitchFamily="34" charset="0"/>
               <a:buChar char="•"/>
+              <a:spcBef>
+                <a:spcPts val="500"/>
+              </a:spcBef>
             </a:pPr>
             <a:r>
               <a:rPr lang="en-US" sz="1400" dirty="0">
@@ -6975,6 +7845,9 @@
             <a:pPr marL="285750" indent="-285750" algn="just">
               <a:buFont typeface="Arial" panose="020B0604020202020204" pitchFamily="34" charset="0"/>
               <a:buChar char="•"/>
+              <a:spcBef>
+                <a:spcPts val="500"/>
+              </a:spcBef>
             </a:pPr>
             <a:r>
               <a:rPr lang="en-US" sz="1400" dirty="0">
@@ -6988,6 +7861,9 @@
             <a:pPr marL="285750" indent="-285750" algn="just">
               <a:buFont typeface="Arial" panose="020B0604020202020204" pitchFamily="34" charset="0"/>
               <a:buChar char="•"/>
+              <a:spcBef>
+                <a:spcPts val="500"/>
+              </a:spcBef>
             </a:pPr>
             <a:r>
               <a:rPr lang="en-US" sz="1400" dirty="0">
@@ -7001,6 +7877,9 @@
             <a:pPr marL="285750" indent="-285750">
               <a:buFont typeface="Wingdings" panose="05000000000000000000" pitchFamily="2" charset="2"/>
               <a:buChar char="v"/>
+              <a:spcBef>
+                <a:spcPts val="900"/>
+              </a:spcBef>
             </a:pPr>
             <a:r>
               <a:rPr lang="en-US" sz="1650" b="1" u="sng" dirty="0">
@@ -7017,6 +7896,9 @@
             <a:pPr marL="285750" indent="-285750" algn="just">
               <a:buFont typeface="Arial" panose="020B0604020202020204" pitchFamily="34" charset="0"/>
               <a:buChar char="•"/>
+              <a:spcBef>
+                <a:spcPts val="500"/>
+              </a:spcBef>
             </a:pPr>
             <a:r>
               <a:rPr lang="en-US" sz="1400" b="1" dirty="0">
@@ -7037,6 +7919,9 @@
             <a:pPr marL="285750" indent="-285750" algn="just">
               <a:buFont typeface="Arial" panose="020B0604020202020204" pitchFamily="34" charset="0"/>
               <a:buChar char="•"/>
+              <a:spcBef>
+                <a:spcPts val="500"/>
+              </a:spcBef>
             </a:pPr>
             <a:r>
               <a:rPr lang="en-US" sz="1400" b="1" dirty="0">
@@ -7050,26 +7935,16 @@
                 <a:latin typeface="Arial" panose="020B0604020202020204" pitchFamily="34" charset="0"/>
                 <a:cs typeface="Arial" panose="020B0604020202020204" pitchFamily="34" charset="0"/>
               </a:rPr>
-              <a:t>published airline tariff sheets were tested empirically against 14 archived sheets and rejected — a fare level is a band, not a price (median max/min 1.25–1.52×), and the route panel churns to 46.6% survival in a single step.</a:t>
-            </a:r>
-          </a:p>
-          <a:p>
-            <a:pPr marL="285750" indent="-285750" algn="just">
-              <a:buFont typeface="Arial" panose="020B0604020202020204" pitchFamily="34" charset="0"/>
-              <a:buChar char="•"/>
-            </a:pPr>
-            <a:r>
-              <a:rPr lang="en-US" sz="1400" dirty="0">
-                <a:latin typeface="Arial" panose="020B0604020202020204" pitchFamily="34" charset="0"/>
-                <a:cs typeface="Arial" panose="020B0604020202020204" pitchFamily="34" charset="0"/>
-              </a:rPr>
-              <a:t>source blocking, anti-bot defences, and free-tier terms changing without notice.</a:t>
+              <a:t>published airline tariff sheets were tested against 14 archived sheets and rejected — a fare level is a band, not a price (median max/min 1.25–1.52×), and the route panel churns to 46.6% survival in one step.</a:t>
             </a:r>
           </a:p>
           <a:p>
             <a:pPr marL="285750" indent="-285750">
               <a:buFont typeface="Wingdings" panose="05000000000000000000" pitchFamily="2" charset="2"/>
               <a:buChar char="v"/>
+              <a:spcBef>
+                <a:spcPts val="900"/>
+              </a:spcBef>
             </a:pPr>
             <a:r>
               <a:rPr lang="en-US" sz="1650" b="1" u="sng" dirty="0">
@@ -7080,66 +7955,6 @@
                 <a:cs typeface="Arial" panose="020B0604020202020204" pitchFamily="34" charset="0"/>
               </a:rPr>
               <a:t>Strategies for overcoming these challenges</a:t>
-            </a:r>
-          </a:p>
-          <a:p>
-            <a:pPr marL="285750" indent="-285750" algn="just">
-              <a:buFont typeface="Arial" panose="020B0604020202020204" pitchFamily="34" charset="0"/>
-              <a:buChar char="•"/>
-            </a:pPr>
-            <a:r>
-              <a:rPr lang="en-US" sz="1400" b="1" dirty="0">
-                <a:latin typeface="Arial" panose="020B0604020202020204" pitchFamily="34" charset="0"/>
-                <a:cs typeface="Arial" panose="020B0604020202020204" pitchFamily="34" charset="0"/>
-              </a:rPr>
-              <a:t>Institutional permission: </a:t>
-            </a:r>
-            <a:r>
-              <a:rPr lang="en-US" sz="1400" dirty="0">
-                <a:latin typeface="Arial" panose="020B0604020202020204" pitchFamily="34" charset="0"/>
-                <a:cs typeface="Arial" panose="020B0604020202020204" pitchFamily="34" charset="0"/>
-              </a:rPr>
-              <a:t>written to MoSPI's Price Statistics Division for methodological guidance, a letter of support, and an introduction to the online platforms the Ministry already collects from; DGCA approached in parallel.</a:t>
-            </a:r>
-          </a:p>
-          <a:p>
-            <a:pPr marL="285750" indent="-285750" algn="just">
-              <a:buFont typeface="Arial" panose="020B0604020202020204" pitchFamily="34" charset="0"/>
-              <a:buChar char="•"/>
-            </a:pPr>
-            <a:r>
-              <a:rPr lang="en-US" sz="1400" b="1" dirty="0">
-                <a:latin typeface="Arial" panose="020B0604020202020204" pitchFamily="34" charset="0"/>
-                <a:cs typeface="Arial" panose="020B0604020202020204" pitchFamily="34" charset="0"/>
-              </a:rPr>
-              <a:t>Costed fallback: </a:t>
-            </a:r>
-            <a:r>
-              <a:rPr lang="en-US" sz="1400" dirty="0">
-                <a:latin typeface="Arial" panose="020B0604020202020204" pitchFamily="34" charset="0"/>
-                <a:cs typeface="Arial" panose="020B0604020202020204" pitchFamily="34" charset="0"/>
-              </a:rPr>
-              <a:t>a licensed fare-data API covers the demo panel at ~$25/month and the full 60-route panel at ~$99/month, with a decision date set in advance so the fallback triggers on time rather than in panic.</a:t>
-            </a:r>
-          </a:p>
-          <a:p>
-            <a:pPr marL="285750" indent="-285750" algn="just">
-              <a:buFont typeface="Arial" panose="020B0604020202020204" pitchFamily="34" charset="0"/>
-              <a:buChar char="•"/>
-            </a:pPr>
-            <a:r>
-              <a:rPr lang="en-US" sz="1400" b="1" dirty="0">
-                <a:latin typeface="Arial" panose="020B0604020202020204" pitchFamily="34" charset="0"/>
-                <a:cs typeface="Arial" panose="020B0604020202020204" pitchFamily="34" charset="0"/>
-              </a:rPr>
-              <a:t>Redundancy, not evasion: </a:t>
-            </a:r>
-            <a:r>
-              <a:rPr lang="en-US" sz="1400" dirty="0">
-                <a:latin typeface="Arial" panose="020B0604020202020204" pitchFamily="34" charset="0"/>
-                <a:cs typeface="Arial" panose="020B0604020202020204" pitchFamily="34" charset="0"/>
-              </a:rPr>
-              <a:t>when a source blocks, it is dropped and the coverage ratio is published — degradation is visible in the statistics, never hidden.</a:t>
             </a:r>
           </a:p>
         </p:txBody>
@@ -7265,7 +8080,7 @@
               <a:defRPr/>
             </a:pPr>
             <a:r>
-              <a:rPr kumimoji="0" lang="en-US" sz="1200" b="0" i="0" u="none" strike="noStrike" kern="1200" cap="none" spc="0" normalizeH="0" baseline="0" noProof="0" dirty="0">
+              <a:rPr kumimoji="0" lang="en-US" sz="1200" b="0" i="0" u="none" strike="noStrike" kern="1200" cap="none" spc="0" normalizeH="0" baseline="0" noProof="0">
                 <a:ln>
                   <a:noFill/>
                 </a:ln>
@@ -7279,8 +8094,22 @@
                 <a:ea typeface="+mn-ea"/>
                 <a:cs typeface="+mn-cs"/>
               </a:rPr>
-              <a:t>@SIH Idea submission</a:t>
-            </a:r>
+              <a:t>@SIH Idea submission- Template</a:t>
+            </a:r>
+            <a:endParaRPr kumimoji="0" lang="en-US" sz="1200" b="0" i="0" u="none" strike="noStrike" kern="1200" cap="none" spc="0" normalizeH="0" baseline="0" noProof="0" dirty="0">
+              <a:ln>
+                <a:noFill/>
+              </a:ln>
+              <a:solidFill>
+                <a:prstClr val="white"/>
+              </a:solidFill>
+              <a:effectLst/>
+              <a:uLnTx/>
+              <a:uFillTx/>
+              <a:latin typeface="TradeGothic"/>
+              <a:ea typeface="+mn-ea"/>
+              <a:cs typeface="+mn-cs"/>
+            </a:endParaRPr>
           </a:p>
         </p:txBody>
       </p:sp>
@@ -7292,7 +8121,7 @@
                 <a16:creationId xmlns:a16="http://schemas.microsoft.com/office/drawing/2014/main" id="{5DBCE864-823D-4A13-9607-5DA1F0ED5FB8}"/>
               </a:ext>
               <a:ext uri="{C183D7F6-B498-43B3-948B-1728B52AA6E4}">
-                <adec:decorative xmlns:adec="http://schemas.microsoft.com/office/drawing/2017/decorative" val="0"/>
+                <adec:decorative xmlns:adec="http://schemas.microsoft.com/office/drawing/2017/decorative" xmlns="" val="0"/>
               </a:ext>
             </a:extLst>
           </p:cNvPr>
@@ -7328,10 +8157,10 @@
           <a:p>
             <a:pPr algn="ctr"/>
             <a:r>
-              <a:rPr lang="en-US" sz="1600" dirty="0"/>
-              <a:t>Copilots</a:t>
-            </a:r>
-            <a:endParaRPr lang="en-IN" sz="1600" dirty="0"/>
+              <a:rPr lang="en-US" sz="1000" dirty="0"/>
+              <a:t>[TEAM NAME]</a:t>
+            </a:r>
+            <a:endParaRPr lang="en-IN" dirty="0"/>
           </a:p>
         </p:txBody>
       </p:sp>
@@ -7365,6 +8194,303 @@
           </a:prstGeom>
         </p:spPr>
       </p:pic>
+      <p:sp>
+        <p:nvSpPr>
+          <p:cNvPr id="918" name="roundRect918"/>
+          <p:cNvSpPr/>
+          <p:nvPr/>
+        </p:nvSpPr>
+        <p:spPr>
+          <a:xfrm>
+            <a:off x="475488" y="4626864"/>
+            <a:ext cx="3566160" cy="987552"/>
+          </a:xfrm>
+          <a:prstGeom prst="roundRect">
+            <a:avLst>
+              <a:gd name="adj" fmla="val 6000"/>
+            </a:avLst>
+          </a:prstGeom>
+          <a:solidFill>
+            <a:srgbClr val="FFFFFF"/>
+          </a:solidFill>
+          <a:ln w="15875">
+            <a:solidFill>
+              <a:srgbClr val="1F497D"/>
+            </a:solidFill>
+          </a:ln>
+        </p:spPr>
+        <p:txBody>
+          <a:bodyPr lIns="128016" rIns="128016" tIns="18000" bIns="18000" anchor="t" wrap="square">
+            <a:normAutofit/>
+          </a:bodyPr>
+          <a:lstStyle/>
+          <a:p>
+            <a:pPr algn="ctr"/>
+            <a:r>
+              <a:rPr lang="en-US" sz="900" b="1" dirty="0">
+                <a:solidFill>
+                  <a:srgbClr val="1F497D"/>
+                </a:solidFill>
+                <a:latin typeface="Arial" panose="020B0604020202020204" pitchFamily="34" charset="0"/>
+                <a:cs typeface="Arial" panose="020B0604020202020204" pitchFamily="34" charset="0"/>
+              </a:rPr>
+              <a:t>INSTITUTIONAL PERMISSION</a:t>
+            </a:r>
+          </a:p>
+          <a:p>
+            <a:pPr algn="ctr"/>
+            <a:r>
+              <a:rPr lang="en-US" sz="850" b="0" dirty="0">
+                <a:solidFill>
+                  <a:srgbClr val="1A1A1A"/>
+                </a:solidFill>
+                <a:latin typeface="Arial" panose="020B0604020202020204" pitchFamily="34" charset="0"/>
+                <a:cs typeface="Arial" panose="020B0604020202020204" pitchFamily="34" charset="0"/>
+              </a:rPr>
+              <a:t>Written to MoSPI Price Statistics Division for guidance, a letter of support and an introduction to the platforms it already collects from. DGCA approached in parallel.</a:t>
+            </a:r>
+          </a:p>
+        </p:txBody>
+      </p:sp>
+      <p:sp>
+        <p:nvSpPr>
+          <p:cNvPr id="919" name="ellipse919"/>
+          <p:cNvSpPr/>
+          <p:nvPr/>
+        </p:nvSpPr>
+        <p:spPr>
+          <a:xfrm>
+            <a:off x="603504" y="4471416"/>
+            <a:ext cx="329184" cy="329184"/>
+          </a:xfrm>
+          <a:prstGeom prst="ellipse">
+            <a:avLst/>
+          </a:prstGeom>
+          <a:solidFill>
+            <a:srgbClr val="1F497D"/>
+          </a:solidFill>
+          <a:ln>
+            <a:noFill/>
+          </a:ln>
+        </p:spPr>
+        <p:txBody>
+          <a:bodyPr lIns="45720" rIns="45720" tIns="18000" bIns="18000" anchor="ctr" wrap="square">
+            <a:normAutofit/>
+          </a:bodyPr>
+          <a:lstStyle/>
+          <a:p>
+            <a:pPr algn="ctr"/>
+            <a:r>
+              <a:rPr lang="en-US" sz="1000" b="1" dirty="0">
+                <a:solidFill>
+                  <a:srgbClr val="FFFFFF"/>
+                </a:solidFill>
+                <a:latin typeface="Arial" panose="020B0604020202020204" pitchFamily="34" charset="0"/>
+                <a:cs typeface="Arial" panose="020B0604020202020204" pitchFamily="34" charset="0"/>
+              </a:rPr>
+              <a:t>1</a:t>
+            </a:r>
+          </a:p>
+        </p:txBody>
+      </p:sp>
+      <p:sp>
+        <p:nvSpPr>
+          <p:cNvPr id="920" name="roundRect920"/>
+          <p:cNvSpPr/>
+          <p:nvPr/>
+        </p:nvSpPr>
+        <p:spPr>
+          <a:xfrm>
+            <a:off x="4297679" y="4626864"/>
+            <a:ext cx="3566160" cy="987552"/>
+          </a:xfrm>
+          <a:prstGeom prst="roundRect">
+            <a:avLst>
+              <a:gd name="adj" fmla="val 6000"/>
+            </a:avLst>
+          </a:prstGeom>
+          <a:solidFill>
+            <a:srgbClr val="FFFFFF"/>
+          </a:solidFill>
+          <a:ln w="15875">
+            <a:solidFill>
+              <a:srgbClr val="4F81BD"/>
+            </a:solidFill>
+          </a:ln>
+        </p:spPr>
+        <p:txBody>
+          <a:bodyPr lIns="128016" rIns="128016" tIns="18000" bIns="18000" anchor="t" wrap="square">
+            <a:normAutofit/>
+          </a:bodyPr>
+          <a:lstStyle/>
+          <a:p>
+            <a:pPr algn="ctr"/>
+            <a:r>
+              <a:rPr lang="en-US" sz="900" b="1" dirty="0">
+                <a:solidFill>
+                  <a:srgbClr val="4F81BD"/>
+                </a:solidFill>
+                <a:latin typeface="Arial" panose="020B0604020202020204" pitchFamily="34" charset="0"/>
+                <a:cs typeface="Arial" panose="020B0604020202020204" pitchFamily="34" charset="0"/>
+              </a:rPr>
+              <a:t>COSTED FALLBACK</a:t>
+            </a:r>
+          </a:p>
+          <a:p>
+            <a:pPr algn="ctr"/>
+            <a:r>
+              <a:rPr lang="en-US" sz="850" b="0" dirty="0">
+                <a:solidFill>
+                  <a:srgbClr val="1A1A1A"/>
+                </a:solidFill>
+                <a:latin typeface="Arial" panose="020B0604020202020204" pitchFamily="34" charset="0"/>
+                <a:cs typeface="Arial" panose="020B0604020202020204" pitchFamily="34" charset="0"/>
+              </a:rPr>
+              <a:t>A licensed fare-data API covers the demo panel at ~$25/month and the full 60-route panel at ~$99/month, with the switch-over date fixed in advance.</a:t>
+            </a:r>
+          </a:p>
+        </p:txBody>
+      </p:sp>
+      <p:sp>
+        <p:nvSpPr>
+          <p:cNvPr id="921" name="ellipse921"/>
+          <p:cNvSpPr/>
+          <p:nvPr/>
+        </p:nvSpPr>
+        <p:spPr>
+          <a:xfrm>
+            <a:off x="4425695" y="4471416"/>
+            <a:ext cx="329184" cy="329184"/>
+          </a:xfrm>
+          <a:prstGeom prst="ellipse">
+            <a:avLst/>
+          </a:prstGeom>
+          <a:solidFill>
+            <a:srgbClr val="4F81BD"/>
+          </a:solidFill>
+          <a:ln>
+            <a:noFill/>
+          </a:ln>
+        </p:spPr>
+        <p:txBody>
+          <a:bodyPr lIns="45720" rIns="45720" tIns="18000" bIns="18000" anchor="ctr" wrap="square">
+            <a:normAutofit/>
+          </a:bodyPr>
+          <a:lstStyle/>
+          <a:p>
+            <a:pPr algn="ctr"/>
+            <a:r>
+              <a:rPr lang="en-US" sz="1000" b="1" dirty="0">
+                <a:solidFill>
+                  <a:srgbClr val="FFFFFF"/>
+                </a:solidFill>
+                <a:latin typeface="Arial" panose="020B0604020202020204" pitchFamily="34" charset="0"/>
+                <a:cs typeface="Arial" panose="020B0604020202020204" pitchFamily="34" charset="0"/>
+              </a:rPr>
+              <a:t>2</a:t>
+            </a:r>
+          </a:p>
+        </p:txBody>
+      </p:sp>
+      <p:sp>
+        <p:nvSpPr>
+          <p:cNvPr id="922" name="roundRect922"/>
+          <p:cNvSpPr/>
+          <p:nvPr/>
+        </p:nvSpPr>
+        <p:spPr>
+          <a:xfrm>
+            <a:off x="8119871" y="4626864"/>
+            <a:ext cx="3566160" cy="987552"/>
+          </a:xfrm>
+          <a:prstGeom prst="roundRect">
+            <a:avLst>
+              <a:gd name="adj" fmla="val 6000"/>
+            </a:avLst>
+          </a:prstGeom>
+          <a:solidFill>
+            <a:srgbClr val="FFFFFF"/>
+          </a:solidFill>
+          <a:ln w="15875">
+            <a:solidFill>
+              <a:srgbClr val="77933C"/>
+            </a:solidFill>
+          </a:ln>
+        </p:spPr>
+        <p:txBody>
+          <a:bodyPr lIns="128016" rIns="128016" tIns="18000" bIns="18000" anchor="t" wrap="square">
+            <a:normAutofit/>
+          </a:bodyPr>
+          <a:lstStyle/>
+          <a:p>
+            <a:pPr algn="ctr"/>
+            <a:r>
+              <a:rPr lang="en-US" sz="900" b="1" dirty="0">
+                <a:solidFill>
+                  <a:srgbClr val="77933C"/>
+                </a:solidFill>
+                <a:latin typeface="Arial" panose="020B0604020202020204" pitchFamily="34" charset="0"/>
+                <a:cs typeface="Arial" panose="020B0604020202020204" pitchFamily="34" charset="0"/>
+              </a:rPr>
+              <a:t>REDUNDANCY, NOT EVASION</a:t>
+            </a:r>
+          </a:p>
+          <a:p>
+            <a:pPr algn="ctr"/>
+            <a:r>
+              <a:rPr lang="en-US" sz="850" b="0" dirty="0">
+                <a:solidFill>
+                  <a:srgbClr val="1A1A1A"/>
+                </a:solidFill>
+                <a:latin typeface="Arial" panose="020B0604020202020204" pitchFamily="34" charset="0"/>
+                <a:cs typeface="Arial" panose="020B0604020202020204" pitchFamily="34" charset="0"/>
+              </a:rPr>
+              <a:t>When a source blocks it is dropped and the coverage ratio is published — degradation is visible in the statistics, never hidden.</a:t>
+            </a:r>
+          </a:p>
+        </p:txBody>
+      </p:sp>
+      <p:sp>
+        <p:nvSpPr>
+          <p:cNvPr id="923" name="ellipse923"/>
+          <p:cNvSpPr/>
+          <p:nvPr/>
+        </p:nvSpPr>
+        <p:spPr>
+          <a:xfrm>
+            <a:off x="8247888" y="4471416"/>
+            <a:ext cx="329184" cy="329184"/>
+          </a:xfrm>
+          <a:prstGeom prst="ellipse">
+            <a:avLst/>
+          </a:prstGeom>
+          <a:solidFill>
+            <a:srgbClr val="77933C"/>
+          </a:solidFill>
+          <a:ln>
+            <a:noFill/>
+          </a:ln>
+        </p:spPr>
+        <p:txBody>
+          <a:bodyPr lIns="45720" rIns="45720" tIns="18000" bIns="18000" anchor="ctr" wrap="square">
+            <a:normAutofit/>
+          </a:bodyPr>
+          <a:lstStyle/>
+          <a:p>
+            <a:pPr algn="ctr"/>
+            <a:r>
+              <a:rPr lang="en-US" sz="1000" b="1" dirty="0">
+                <a:solidFill>
+                  <a:srgbClr val="FFFFFF"/>
+                </a:solidFill>
+                <a:latin typeface="Arial" panose="020B0604020202020204" pitchFamily="34" charset="0"/>
+                <a:cs typeface="Arial" panose="020B0604020202020204" pitchFamily="34" charset="0"/>
+              </a:rPr>
+              <a:t>3</a:t>
+            </a:r>
+          </a:p>
+        </p:txBody>
+      </p:sp>
     </p:spTree>
     <p:extLst>
       <p:ext uri="{BB962C8B-B14F-4D97-AF65-F5344CB8AC3E}">
@@ -7512,7 +8638,7 @@
         <p:spPr bwMode="auto">
           <a:xfrm>
             <a:off x="457200" y="1298448"/>
-            <a:ext cx="11292840" cy="4956048"/>
+            <a:ext cx="11292840" cy="3127248"/>
           </a:xfrm>
           <a:prstGeom prst="rect">
             <a:avLst/>
@@ -7534,6 +8660,9 @@
             <a:pPr marL="285750" indent="-285750">
               <a:buFont typeface="Wingdings" panose="05000000000000000000" pitchFamily="2" charset="2"/>
               <a:buChar char="v"/>
+              <a:spcBef>
+                <a:spcPts val="900"/>
+              </a:spcBef>
             </a:pPr>
             <a:r>
               <a:rPr lang="en-US" sz="1650" b="1" u="sng" dirty="0">
@@ -7543,73 +8672,85 @@
                 <a:latin typeface="Arial" panose="020B0604020202020204" pitchFamily="34" charset="0"/>
                 <a:cs typeface="Arial" panose="020B0604020202020204" pitchFamily="34" charset="0"/>
               </a:rPr>
-              <a:t>Potential impact on the target audience</a:t>
+              <a:t>Benefits of the solution</a:t>
             </a:r>
           </a:p>
           <a:p>
             <a:pPr marL="285750" indent="-285750" algn="just">
               <a:buFont typeface="Arial" panose="020B0604020202020204" pitchFamily="34" charset="0"/>
               <a:buChar char="•"/>
+              <a:spcBef>
+                <a:spcPts val="500"/>
+              </a:spcBef>
             </a:pPr>
             <a:r>
               <a:rPr lang="en-US" sz="1400" b="1" dirty="0">
                 <a:latin typeface="Arial" panose="020B0604020202020204" pitchFamily="34" charset="0"/>
                 <a:cs typeface="Arial" panose="020B0604020202020204" pitchFamily="34" charset="0"/>
               </a:rPr>
-              <a:t>MoSPI: </a:t>
+              <a:t>Economic: </a:t>
             </a:r>
             <a:r>
               <a:rPr lang="en-US" sz="1400" dirty="0">
                 <a:latin typeface="Arial" panose="020B0604020202020204" pitchFamily="34" charset="0"/>
                 <a:cs typeface="Arial" panose="020B0604020202020204" pitchFamily="34" charset="0"/>
               </a:rPr>
-              <a:t>a daily airfare series with route, carrier and booking-horizon detail beneath the monthly CPI item — the granularity an item index cannot carry, with imputation share and coverage disclosed on every point.</a:t>
+              <a:t>₹0 recurring cost, no vendor lock-in and no licensing conversation — the system can be handed to the Ministry without a budget line.</a:t>
             </a:r>
           </a:p>
           <a:p>
             <a:pPr marL="285750" indent="-285750" algn="just">
               <a:buFont typeface="Arial" panose="020B0604020202020204" pitchFamily="34" charset="0"/>
               <a:buChar char="•"/>
+              <a:spcBef>
+                <a:spcPts val="500"/>
+              </a:spcBef>
             </a:pPr>
             <a:r>
               <a:rPr lang="en-US" sz="1400" b="1" dirty="0">
                 <a:latin typeface="Arial" panose="020B0604020202020204" pitchFamily="34" charset="0"/>
                 <a:cs typeface="Arial" panose="020B0604020202020204" pitchFamily="34" charset="0"/>
               </a:rPr>
-              <a:t>DGCA: </a:t>
+              <a:t>Social: </a:t>
             </a:r>
             <a:r>
               <a:rPr lang="en-US" sz="1400" dirty="0">
                 <a:latin typeface="Arial" panose="020B0604020202020204" pitchFamily="34" charset="0"/>
                 <a:cs typeface="Arial" panose="020B0604020202020204" pitchFamily="34" charset="0"/>
               </a:rPr>
-              <a:t>a continuously observed, horizon-controlled panel turns periodic tariff spot-checks into a series: which routes move, how far ahead movement begins, and whether a festival window or capacity change is driving it.</a:t>
+              <a:t>an index that publishes its own coverage ratio and imputation share, with open methodology and open code — trust through disclosure rather than assertion.</a:t>
             </a:r>
           </a:p>
           <a:p>
             <a:pPr marL="285750" indent="-285750" algn="just">
               <a:buFont typeface="Arial" panose="020B0604020202020204" pitchFamily="34" charset="0"/>
               <a:buChar char="•"/>
+              <a:spcBef>
+                <a:spcPts val="500"/>
+              </a:spcBef>
             </a:pPr>
             <a:r>
               <a:rPr lang="en-US" sz="1400" b="1" dirty="0">
                 <a:latin typeface="Arial" panose="020B0604020202020204" pitchFamily="34" charset="0"/>
                 <a:cs typeface="Arial" panose="020B0604020202020204" pitchFamily="34" charset="0"/>
               </a:rPr>
-              <a:t>Travellers and the public: </a:t>
+              <a:t>Systemic: </a:t>
             </a:r>
             <a:r>
               <a:rPr lang="en-US" sz="1400" dirty="0">
                 <a:latin typeface="Arial" panose="020B0604020202020204" pitchFamily="34" charset="0"/>
                 <a:cs typeface="Arial" panose="020B0604020202020204" pitchFamily="34" charset="0"/>
               </a:rPr>
-              <a:t>how far ahead to book on a given route, what a festival window costs, and how last-minute pricing differs between full-service and low-cost carriers. The calendar already encodes 8 festivals and 3 vacation windows.</a:t>
+              <a:t>the reproducibility machinery — append-only archive, hashed config, pure index function, golden tests — is reusable for any high-frequency price collection the statistical system takes on.</a:t>
             </a:r>
           </a:p>
           <a:p>
             <a:pPr marL="285750" indent="-285750">
               <a:buFont typeface="Wingdings" panose="05000000000000000000" pitchFamily="2" charset="2"/>
               <a:buChar char="v"/>
+              <a:spcBef>
+                <a:spcPts val="900"/>
+              </a:spcBef>
             </a:pPr>
             <a:r>
               <a:rPr lang="en-US" sz="1650" b="1" u="sng" dirty="0">
@@ -7619,102 +8760,32 @@
                 <a:latin typeface="Arial" panose="020B0604020202020204" pitchFamily="34" charset="0"/>
                 <a:cs typeface="Arial" panose="020B0604020202020204" pitchFamily="34" charset="0"/>
               </a:rPr>
-              <a:t>Benefits of the solution</a:t>
+              <a:t>Independently corroborated</a:t>
             </a:r>
           </a:p>
           <a:p>
             <a:pPr marL="285750" indent="-285750" algn="just">
               <a:buFont typeface="Arial" panose="020B0604020202020204" pitchFamily="34" charset="0"/>
               <a:buChar char="•"/>
+              <a:spcBef>
+                <a:spcPts val="500"/>
+              </a:spcBef>
             </a:pPr>
             <a:r>
-              <a:rPr lang="en-US" sz="1400" b="1" dirty="0">
-                <a:latin typeface="Arial" panose="020B0604020202020204" pitchFamily="34" charset="0"/>
-                <a:cs typeface="Arial" panose="020B0604020202020204" pitchFamily="34" charset="0"/>
-              </a:rPr>
-              <a:t>Economic: </a:t>
-            </a:r>
-            <a:r>
               <a:rPr lang="en-US" sz="1400" dirty="0">
                 <a:latin typeface="Arial" panose="020B0604020202020204" pitchFamily="34" charset="0"/>
                 <a:cs typeface="Arial" panose="020B0604020202020204" pitchFamily="34" charset="0"/>
               </a:rPr>
-              <a:t>₹0 recurring cost, no vendor lock-in, and no licensing conversation — the system can be handed to the Ministry without a budget line.</a:t>
+              <a:t>MoSPI's own CPI 2024 series uses Jevons for elementary indices and a Laspeyres-family aggregation above it — the two most consequential choices AeroDex arrived at independently.</a:t>
             </a:r>
           </a:p>
           <a:p>
             <a:pPr marL="285750" indent="-285750" algn="just">
               <a:buFont typeface="Arial" panose="020B0604020202020204" pitchFamily="34" charset="0"/>
               <a:buChar char="•"/>
-            </a:pPr>
-            <a:r>
-              <a:rPr lang="en-US" sz="1400" b="1" dirty="0">
-                <a:latin typeface="Arial" panose="020B0604020202020204" pitchFamily="34" charset="0"/>
-                <a:cs typeface="Arial" panose="020B0604020202020204" pitchFamily="34" charset="0"/>
-              </a:rPr>
-              <a:t>Social: </a:t>
-            </a:r>
-            <a:r>
-              <a:rPr lang="en-US" sz="1400" dirty="0">
-                <a:latin typeface="Arial" panose="020B0604020202020204" pitchFamily="34" charset="0"/>
-                <a:cs typeface="Arial" panose="020B0604020202020204" pitchFamily="34" charset="0"/>
-              </a:rPr>
-              <a:t>an index that publishes its own coverage ratio and imputation share, with open methodology and open code — trust through disclosure rather than assertion.</a:t>
-            </a:r>
-          </a:p>
-          <a:p>
-            <a:pPr marL="285750" indent="-285750" algn="just">
-              <a:buFont typeface="Arial" panose="020B0604020202020204" pitchFamily="34" charset="0"/>
-              <a:buChar char="•"/>
-            </a:pPr>
-            <a:r>
-              <a:rPr lang="en-US" sz="1400" b="1" dirty="0">
-                <a:latin typeface="Arial" panose="020B0604020202020204" pitchFamily="34" charset="0"/>
-                <a:cs typeface="Arial" panose="020B0604020202020204" pitchFamily="34" charset="0"/>
-              </a:rPr>
-              <a:t>Systemic: </a:t>
-            </a:r>
-            <a:r>
-              <a:rPr lang="en-US" sz="1400" dirty="0">
-                <a:latin typeface="Arial" panose="020B0604020202020204" pitchFamily="34" charset="0"/>
-                <a:cs typeface="Arial" panose="020B0604020202020204" pitchFamily="34" charset="0"/>
-              </a:rPr>
-              <a:t>the reproducibility machinery — append-only archive, hashed config, pure index function, golden tests — is not airfare-specific and can be reused for any high-frequency price collection the statistical system takes on.</a:t>
-            </a:r>
-          </a:p>
-          <a:p>
-            <a:pPr marL="285750" indent="-285750">
-              <a:buFont typeface="Wingdings" panose="05000000000000000000" pitchFamily="2" charset="2"/>
-              <a:buChar char="v"/>
-            </a:pPr>
-            <a:r>
-              <a:rPr lang="en-US" sz="1650" b="1" u="sng" dirty="0">
-                <a:solidFill>
-                  <a:schemeClr val="tx2"/>
-                </a:solidFill>
-                <a:latin typeface="Arial" panose="020B0604020202020204" pitchFamily="34" charset="0"/>
-                <a:cs typeface="Arial" panose="020B0604020202020204" pitchFamily="34" charset="0"/>
-              </a:rPr>
-              <a:t>Independently corroborated</a:t>
-            </a:r>
-          </a:p>
-          <a:p>
-            <a:pPr marL="285750" indent="-285750" algn="just">
-              <a:buFont typeface="Arial" panose="020B0604020202020204" pitchFamily="34" charset="0"/>
-              <a:buChar char="•"/>
-            </a:pPr>
-            <a:r>
-              <a:rPr lang="en-US" sz="1400" dirty="0">
-                <a:latin typeface="Arial" panose="020B0604020202020204" pitchFamily="34" charset="0"/>
-                <a:cs typeface="Arial" panose="020B0604020202020204" pitchFamily="34" charset="0"/>
-              </a:rPr>
-              <a:t>MoSPI's own CPI 2024 series uses Jevons for elementary indices and a Laspeyres-family aggregation above it — the two most consequential choices AeroDex arrived at independently.</a:t>
-            </a:r>
-          </a:p>
-          <a:p>
-            <a:pPr marL="285750" indent="-285750" algn="just">
-              <a:buFont typeface="Arial" panose="020B0604020202020204" pitchFamily="34" charset="0"/>
-              <a:buChar char="•"/>
+              <a:spcBef>
+                <a:spcPts val="500"/>
+              </a:spcBef>
             </a:pPr>
             <a:r>
               <a:rPr lang="en-US" sz="1400" dirty="0">
@@ -7847,7 +8918,7 @@
               <a:defRPr/>
             </a:pPr>
             <a:r>
-              <a:rPr kumimoji="0" lang="en-US" sz="1200" b="0" i="0" u="none" strike="noStrike" kern="1200" cap="none" spc="0" normalizeH="0" baseline="0" noProof="0" dirty="0">
+              <a:rPr kumimoji="0" lang="en-US" sz="1200" b="0" i="0" u="none" strike="noStrike" kern="1200" cap="none" spc="0" normalizeH="0" baseline="0" noProof="0">
                 <a:ln>
                   <a:noFill/>
                 </a:ln>
@@ -7861,8 +8932,22 @@
                 <a:ea typeface="+mn-ea"/>
                 <a:cs typeface="+mn-cs"/>
               </a:rPr>
-              <a:t>@SIH Idea submission</a:t>
-            </a:r>
+              <a:t>@SIH Idea submission- Template</a:t>
+            </a:r>
+            <a:endParaRPr kumimoji="0" lang="en-US" sz="1200" b="0" i="0" u="none" strike="noStrike" kern="1200" cap="none" spc="0" normalizeH="0" baseline="0" noProof="0" dirty="0">
+              <a:ln>
+                <a:noFill/>
+              </a:ln>
+              <a:solidFill>
+                <a:prstClr val="white"/>
+              </a:solidFill>
+              <a:effectLst/>
+              <a:uLnTx/>
+              <a:uFillTx/>
+              <a:latin typeface="TradeGothic"/>
+              <a:ea typeface="+mn-ea"/>
+              <a:cs typeface="+mn-cs"/>
+            </a:endParaRPr>
           </a:p>
         </p:txBody>
       </p:sp>
@@ -7874,7 +8959,7 @@
                 <a16:creationId xmlns:a16="http://schemas.microsoft.com/office/drawing/2014/main" id="{5DBCE864-823D-4A13-9607-5DA1F0ED5FB8}"/>
               </a:ext>
               <a:ext uri="{C183D7F6-B498-43B3-948B-1728B52AA6E4}">
-                <adec:decorative xmlns:adec="http://schemas.microsoft.com/office/drawing/2017/decorative" val="0"/>
+                <adec:decorative xmlns:adec="http://schemas.microsoft.com/office/drawing/2017/decorative" xmlns="" val="0"/>
               </a:ext>
             </a:extLst>
           </p:cNvPr>
@@ -7910,10 +8995,10 @@
           <a:p>
             <a:pPr algn="ctr"/>
             <a:r>
-              <a:rPr lang="en-US" sz="1600" dirty="0"/>
-              <a:t>Copilots</a:t>
-            </a:r>
-            <a:endParaRPr lang="en-IN" sz="1600" dirty="0"/>
+              <a:rPr lang="en-US" sz="1000" dirty="0"/>
+              <a:t>[TEAM NAME]</a:t>
+            </a:r>
+            <a:endParaRPr lang="en-IN" dirty="0"/>
           </a:p>
         </p:txBody>
       </p:sp>
@@ -7947,6 +9032,446 @@
           </a:prstGeom>
         </p:spPr>
       </p:pic>
+      <p:sp>
+        <p:nvSpPr>
+          <p:cNvPr id="924" name="lbl924"/>
+          <p:cNvSpPr txBox="1"/>
+          <p:nvPr/>
+        </p:nvSpPr>
+        <p:spPr>
+          <a:xfrm>
+            <a:off x="475488" y="4681728"/>
+            <a:ext cx="11201400" cy="256032"/>
+          </a:xfrm>
+          <a:prstGeom prst="rect">
+            <a:avLst/>
+          </a:prstGeom>
+          <a:noFill/>
+        </p:spPr>
+        <p:txBody>
+          <a:bodyPr wrap="square" anchor="b">
+            <a:normAutofit/>
+          </a:bodyPr>
+          <a:lstStyle/>
+          <a:p>
+            <a:pPr algn="l"/>
+            <a:r>
+              <a:rPr lang="en-US" sz="1000" b="1" dirty="0">
+                <a:solidFill>
+                  <a:srgbClr val="1F497D"/>
+                </a:solidFill>
+                <a:latin typeface="Arial" panose="020B0604020202020204" pitchFamily="34" charset="0"/>
+                <a:cs typeface="Arial" panose="020B0604020202020204" pitchFamily="34" charset="0"/>
+              </a:rPr>
+              <a:t>POTENTIAL IMPACT ON THE TARGET AUDIENCE</a:t>
+            </a:r>
+          </a:p>
+        </p:txBody>
+      </p:sp>
+      <p:sp>
+        <p:nvSpPr>
+          <p:cNvPr id="925" name="roundRect925"/>
+          <p:cNvSpPr/>
+          <p:nvPr/>
+        </p:nvSpPr>
+        <p:spPr>
+          <a:xfrm>
+            <a:off x="475488" y="5193792"/>
+            <a:ext cx="2724912" cy="841247"/>
+          </a:xfrm>
+          <a:prstGeom prst="roundRect">
+            <a:avLst>
+              <a:gd name="adj" fmla="val 8000"/>
+            </a:avLst>
+          </a:prstGeom>
+          <a:solidFill>
+            <a:srgbClr val="DCE6F1"/>
+          </a:solidFill>
+          <a:ln w="12700">
+            <a:solidFill>
+              <a:srgbClr val="1F497D"/>
+            </a:solidFill>
+          </a:ln>
+        </p:spPr>
+        <p:txBody>
+          <a:bodyPr lIns="109728" rIns="109728" tIns="18000" bIns="18000" anchor="t" wrap="square">
+            <a:normAutofit/>
+          </a:bodyPr>
+          <a:lstStyle/>
+          <a:p>
+            <a:pPr algn="ctr"/>
+            <a:r>
+              <a:rPr lang="en-US" sz="400" b="0" dirty="0">
+                <a:solidFill>
+                  <a:srgbClr val="1A1A1A"/>
+                </a:solidFill>
+                <a:latin typeface="Arial" panose="020B0604020202020204" pitchFamily="34" charset="0"/>
+                <a:cs typeface="Arial" panose="020B0604020202020204" pitchFamily="34" charset="0"/>
+              </a:rPr>
+              <a:t/>
+            </a:r>
+          </a:p>
+          <a:p>
+            <a:pPr algn="ctr"/>
+            <a:r>
+              <a:rPr lang="en-US" sz="850" b="0" dirty="0">
+                <a:solidFill>
+                  <a:srgbClr val="1A1A1A"/>
+                </a:solidFill>
+                <a:latin typeface="Arial" panose="020B0604020202020204" pitchFamily="34" charset="0"/>
+                <a:cs typeface="Arial" panose="020B0604020202020204" pitchFamily="34" charset="0"/>
+              </a:rPr>
+              <a:t>A daily series beneath the monthly CPI air-fare item</a:t>
+            </a:r>
+          </a:p>
+        </p:txBody>
+      </p:sp>
+      <p:sp>
+        <p:nvSpPr>
+          <p:cNvPr id="926" name="roundRect926"/>
+          <p:cNvSpPr/>
+          <p:nvPr/>
+        </p:nvSpPr>
+        <p:spPr>
+          <a:xfrm>
+            <a:off x="749808" y="4956048"/>
+            <a:ext cx="2176272" cy="384048"/>
+          </a:xfrm>
+          <a:prstGeom prst="roundRect">
+            <a:avLst>
+              <a:gd name="adj" fmla="val 32000"/>
+            </a:avLst>
+          </a:prstGeom>
+          <a:solidFill>
+            <a:srgbClr val="1F497D"/>
+          </a:solidFill>
+          <a:ln>
+            <a:noFill/>
+          </a:ln>
+        </p:spPr>
+        <p:txBody>
+          <a:bodyPr lIns="45720" rIns="45720" tIns="18000" bIns="18000" anchor="ctr" wrap="square">
+            <a:normAutofit/>
+          </a:bodyPr>
+          <a:lstStyle/>
+          <a:p>
+            <a:pPr algn="ctr"/>
+            <a:r>
+              <a:rPr lang="en-US" sz="900" b="1" dirty="0">
+                <a:solidFill>
+                  <a:srgbClr val="FFFFFF"/>
+                </a:solidFill>
+                <a:latin typeface="Arial" panose="020B0604020202020204" pitchFamily="34" charset="0"/>
+                <a:cs typeface="Arial" panose="020B0604020202020204" pitchFamily="34" charset="0"/>
+              </a:rPr>
+              <a:t>MoSPI</a:t>
+            </a:r>
+          </a:p>
+        </p:txBody>
+      </p:sp>
+      <p:sp>
+        <p:nvSpPr>
+          <p:cNvPr id="927" name="roundRect927"/>
+          <p:cNvSpPr/>
+          <p:nvPr/>
+        </p:nvSpPr>
+        <p:spPr>
+          <a:xfrm>
+            <a:off x="3447288" y="5193792"/>
+            <a:ext cx="2724912" cy="841247"/>
+          </a:xfrm>
+          <a:prstGeom prst="roundRect">
+            <a:avLst>
+              <a:gd name="adj" fmla="val 8000"/>
+            </a:avLst>
+          </a:prstGeom>
+          <a:solidFill>
+            <a:srgbClr val="DCE6F1"/>
+          </a:solidFill>
+          <a:ln w="12700">
+            <a:solidFill>
+              <a:srgbClr val="4F81BD"/>
+            </a:solidFill>
+          </a:ln>
+        </p:spPr>
+        <p:txBody>
+          <a:bodyPr lIns="109728" rIns="109728" tIns="18000" bIns="18000" anchor="t" wrap="square">
+            <a:normAutofit/>
+          </a:bodyPr>
+          <a:lstStyle/>
+          <a:p>
+            <a:pPr algn="ctr"/>
+            <a:r>
+              <a:rPr lang="en-US" sz="400" b="0" dirty="0">
+                <a:solidFill>
+                  <a:srgbClr val="1A1A1A"/>
+                </a:solidFill>
+                <a:latin typeface="Arial" panose="020B0604020202020204" pitchFamily="34" charset="0"/>
+                <a:cs typeface="Arial" panose="020B0604020202020204" pitchFamily="34" charset="0"/>
+              </a:rPr>
+              <a:t/>
+            </a:r>
+          </a:p>
+          <a:p>
+            <a:pPr algn="ctr"/>
+            <a:r>
+              <a:rPr lang="en-US" sz="850" b="0" dirty="0">
+                <a:solidFill>
+                  <a:srgbClr val="1A1A1A"/>
+                </a:solidFill>
+                <a:latin typeface="Arial" panose="020B0604020202020204" pitchFamily="34" charset="0"/>
+                <a:cs typeface="Arial" panose="020B0604020202020204" pitchFamily="34" charset="0"/>
+              </a:rPr>
+              <a:t>Tariff spot-checks become a continuous, horizon-controlled series</a:t>
+            </a:r>
+          </a:p>
+        </p:txBody>
+      </p:sp>
+      <p:sp>
+        <p:nvSpPr>
+          <p:cNvPr id="928" name="roundRect928"/>
+          <p:cNvSpPr/>
+          <p:nvPr/>
+        </p:nvSpPr>
+        <p:spPr>
+          <a:xfrm>
+            <a:off x="3721608" y="4956048"/>
+            <a:ext cx="2176272" cy="384048"/>
+          </a:xfrm>
+          <a:prstGeom prst="roundRect">
+            <a:avLst>
+              <a:gd name="adj" fmla="val 32000"/>
+            </a:avLst>
+          </a:prstGeom>
+          <a:solidFill>
+            <a:srgbClr val="4F81BD"/>
+          </a:solidFill>
+          <a:ln>
+            <a:noFill/>
+          </a:ln>
+        </p:spPr>
+        <p:txBody>
+          <a:bodyPr lIns="45720" rIns="45720" tIns="18000" bIns="18000" anchor="ctr" wrap="square">
+            <a:normAutofit/>
+          </a:bodyPr>
+          <a:lstStyle/>
+          <a:p>
+            <a:pPr algn="ctr"/>
+            <a:r>
+              <a:rPr lang="en-US" sz="900" b="1" dirty="0">
+                <a:solidFill>
+                  <a:srgbClr val="FFFFFF"/>
+                </a:solidFill>
+                <a:latin typeface="Arial" panose="020B0604020202020204" pitchFamily="34" charset="0"/>
+                <a:cs typeface="Arial" panose="020B0604020202020204" pitchFamily="34" charset="0"/>
+              </a:rPr>
+              <a:t>DGCA</a:t>
+            </a:r>
+          </a:p>
+        </p:txBody>
+      </p:sp>
+      <p:sp>
+        <p:nvSpPr>
+          <p:cNvPr id="929" name="roundRect929"/>
+          <p:cNvSpPr/>
+          <p:nvPr/>
+        </p:nvSpPr>
+        <p:spPr>
+          <a:xfrm>
+            <a:off x="6419088" y="5193792"/>
+            <a:ext cx="2724912" cy="841247"/>
+          </a:xfrm>
+          <a:prstGeom prst="roundRect">
+            <a:avLst>
+              <a:gd name="adj" fmla="val 8000"/>
+            </a:avLst>
+          </a:prstGeom>
+          <a:solidFill>
+            <a:srgbClr val="F7F3EC"/>
+          </a:solidFill>
+          <a:ln w="12700">
+            <a:solidFill>
+              <a:srgbClr val="F79646"/>
+            </a:solidFill>
+          </a:ln>
+        </p:spPr>
+        <p:txBody>
+          <a:bodyPr lIns="109728" rIns="109728" tIns="18000" bIns="18000" anchor="t" wrap="square">
+            <a:normAutofit/>
+          </a:bodyPr>
+          <a:lstStyle/>
+          <a:p>
+            <a:pPr algn="ctr"/>
+            <a:r>
+              <a:rPr lang="en-US" sz="400" b="0" dirty="0">
+                <a:solidFill>
+                  <a:srgbClr val="1A1A1A"/>
+                </a:solidFill>
+                <a:latin typeface="Arial" panose="020B0604020202020204" pitchFamily="34" charset="0"/>
+                <a:cs typeface="Arial" panose="020B0604020202020204" pitchFamily="34" charset="0"/>
+              </a:rPr>
+              <a:t/>
+            </a:r>
+          </a:p>
+          <a:p>
+            <a:pPr algn="ctr"/>
+            <a:r>
+              <a:rPr lang="en-US" sz="850" b="0" dirty="0">
+                <a:solidFill>
+                  <a:srgbClr val="1A1A1A"/>
+                </a:solidFill>
+                <a:latin typeface="Arial" panose="020B0604020202020204" pitchFamily="34" charset="0"/>
+                <a:cs typeface="Arial" panose="020B0604020202020204" pitchFamily="34" charset="0"/>
+              </a:rPr>
+              <a:t>When to book, what a festival window costs, LCC vs full-service</a:t>
+            </a:r>
+          </a:p>
+        </p:txBody>
+      </p:sp>
+      <p:sp>
+        <p:nvSpPr>
+          <p:cNvPr id="930" name="roundRect930"/>
+          <p:cNvSpPr/>
+          <p:nvPr/>
+        </p:nvSpPr>
+        <p:spPr>
+          <a:xfrm>
+            <a:off x="6693407" y="4956048"/>
+            <a:ext cx="2176272" cy="384048"/>
+          </a:xfrm>
+          <a:prstGeom prst="roundRect">
+            <a:avLst>
+              <a:gd name="adj" fmla="val 32000"/>
+            </a:avLst>
+          </a:prstGeom>
+          <a:solidFill>
+            <a:srgbClr val="F79646"/>
+          </a:solidFill>
+          <a:ln>
+            <a:noFill/>
+          </a:ln>
+        </p:spPr>
+        <p:txBody>
+          <a:bodyPr lIns="45720" rIns="45720" tIns="18000" bIns="18000" anchor="ctr" wrap="square">
+            <a:normAutofit/>
+          </a:bodyPr>
+          <a:lstStyle/>
+          <a:p>
+            <a:pPr algn="ctr"/>
+            <a:r>
+              <a:rPr lang="en-US" sz="900" b="1" dirty="0">
+                <a:solidFill>
+                  <a:srgbClr val="FFFFFF"/>
+                </a:solidFill>
+                <a:latin typeface="Arial" panose="020B0604020202020204" pitchFamily="34" charset="0"/>
+                <a:cs typeface="Arial" panose="020B0604020202020204" pitchFamily="34" charset="0"/>
+              </a:rPr>
+              <a:t>TRAVELLERS</a:t>
+            </a:r>
+          </a:p>
+        </p:txBody>
+      </p:sp>
+      <p:sp>
+        <p:nvSpPr>
+          <p:cNvPr id="931" name="roundRect931"/>
+          <p:cNvSpPr/>
+          <p:nvPr/>
+        </p:nvSpPr>
+        <p:spPr>
+          <a:xfrm>
+            <a:off x="9390888" y="5193792"/>
+            <a:ext cx="2724912" cy="841247"/>
+          </a:xfrm>
+          <a:prstGeom prst="roundRect">
+            <a:avLst>
+              <a:gd name="adj" fmla="val 8000"/>
+            </a:avLst>
+          </a:prstGeom>
+          <a:solidFill>
+            <a:srgbClr val="F7F3EC"/>
+          </a:solidFill>
+          <a:ln w="12700">
+            <a:solidFill>
+              <a:srgbClr val="77933C"/>
+            </a:solidFill>
+          </a:ln>
+        </p:spPr>
+        <p:txBody>
+          <a:bodyPr lIns="109728" rIns="109728" tIns="18000" bIns="18000" anchor="t" wrap="square">
+            <a:normAutofit/>
+          </a:bodyPr>
+          <a:lstStyle/>
+          <a:p>
+            <a:pPr algn="ctr"/>
+            <a:r>
+              <a:rPr lang="en-US" sz="400" b="0" dirty="0">
+                <a:solidFill>
+                  <a:srgbClr val="1A1A1A"/>
+                </a:solidFill>
+                <a:latin typeface="Arial" panose="020B0604020202020204" pitchFamily="34" charset="0"/>
+                <a:cs typeface="Arial" panose="020B0604020202020204" pitchFamily="34" charset="0"/>
+              </a:rPr>
+              <a:t/>
+            </a:r>
+          </a:p>
+          <a:p>
+            <a:pPr algn="ctr"/>
+            <a:r>
+              <a:rPr lang="en-US" sz="850" b="0" dirty="0">
+                <a:solidFill>
+                  <a:srgbClr val="1A1A1A"/>
+                </a:solidFill>
+                <a:latin typeface="Arial" panose="020B0604020202020204" pitchFamily="34" charset="0"/>
+                <a:cs typeface="Arial" panose="020B0604020202020204" pitchFamily="34" charset="0"/>
+              </a:rPr>
+              <a:t>Reproducibility machinery reusable for any price collection</a:t>
+            </a:r>
+          </a:p>
+        </p:txBody>
+      </p:sp>
+      <p:sp>
+        <p:nvSpPr>
+          <p:cNvPr id="932" name="roundRect932"/>
+          <p:cNvSpPr/>
+          <p:nvPr/>
+        </p:nvSpPr>
+        <p:spPr>
+          <a:xfrm>
+            <a:off x="9665208" y="4956048"/>
+            <a:ext cx="2176272" cy="384048"/>
+          </a:xfrm>
+          <a:prstGeom prst="roundRect">
+            <a:avLst>
+              <a:gd name="adj" fmla="val 32000"/>
+            </a:avLst>
+          </a:prstGeom>
+          <a:solidFill>
+            <a:srgbClr val="77933C"/>
+          </a:solidFill>
+          <a:ln>
+            <a:noFill/>
+          </a:ln>
+        </p:spPr>
+        <p:txBody>
+          <a:bodyPr lIns="45720" rIns="45720" tIns="18000" bIns="18000" anchor="ctr" wrap="square">
+            <a:normAutofit/>
+          </a:bodyPr>
+          <a:lstStyle/>
+          <a:p>
+            <a:pPr algn="ctr"/>
+            <a:r>
+              <a:rPr lang="en-US" sz="900" b="1" dirty="0">
+                <a:solidFill>
+                  <a:srgbClr val="FFFFFF"/>
+                </a:solidFill>
+                <a:latin typeface="Arial" panose="020B0604020202020204" pitchFamily="34" charset="0"/>
+                <a:cs typeface="Arial" panose="020B0604020202020204" pitchFamily="34" charset="0"/>
+              </a:rPr>
+              <a:t>THE WIDER SYSTEM</a:t>
+            </a:r>
+          </a:p>
+        </p:txBody>
+      </p:sp>
     </p:spTree>
     <p:extLst>
       <p:ext uri="{BB962C8B-B14F-4D97-AF65-F5344CB8AC3E}">
@@ -8094,7 +9619,7 @@
         <p:spPr bwMode="auto">
           <a:xfrm>
             <a:off x="457200" y="1298448"/>
-            <a:ext cx="11292840" cy="4956048"/>
+            <a:ext cx="11292840" cy="3977639"/>
           </a:xfrm>
           <a:prstGeom prst="rect">
             <a:avLst/>
@@ -8116,6 +9641,9 @@
             <a:pPr marL="285750" indent="-285750">
               <a:buFont typeface="Wingdings" panose="05000000000000000000" pitchFamily="2" charset="2"/>
               <a:buChar char="v"/>
+              <a:spcBef>
+                <a:spcPts val="900"/>
+              </a:spcBef>
             </a:pPr>
             <a:r>
               <a:rPr lang="en-US" sz="1650" b="1" u="sng" dirty="0">
@@ -8132,19 +9660,9 @@
             <a:pPr marL="285750" indent="-285750" algn="just">
               <a:buFont typeface="Arial" panose="020B0604020202020204" pitchFamily="34" charset="0"/>
               <a:buChar char="•"/>
-            </a:pPr>
-            <a:r>
-              <a:rPr lang="en-US" sz="1400" dirty="0">
-                <a:latin typeface="Arial" panose="020B0604020202020204" pitchFamily="34" charset="0"/>
-                <a:cs typeface="Arial" panose="020B0604020202020204" pitchFamily="34" charset="0"/>
-              </a:rPr>
-              <a:t>Four adversarial research passes · 40+ candidate sources · nine independent axes per source · 38 claims registered with evidence and confidence · one empirical experiment on 14 archived tariff sheets.</a:t>
-            </a:r>
-          </a:p>
-          <a:p>
-            <a:pPr marL="285750" indent="-285750" algn="just">
-              <a:buFont typeface="Arial" panose="020B0604020202020204" pitchFamily="34" charset="0"/>
-              <a:buChar char="•"/>
+              <a:spcBef>
+                <a:spcPts val="500"/>
+              </a:spcBef>
             </a:pPr>
             <a:r>
               <a:rPr lang="en-US" sz="1400" dirty="0">
@@ -8158,6 +9676,9 @@
             <a:pPr marL="285750" indent="-285750">
               <a:buFont typeface="Wingdings" panose="05000000000000000000" pitchFamily="2" charset="2"/>
               <a:buChar char="v"/>
+              <a:spcBef>
+                <a:spcPts val="900"/>
+              </a:spcBef>
             </a:pPr>
             <a:r>
               <a:rPr lang="en-US" sz="1650" b="1" u="sng" dirty="0">
@@ -8174,6 +9695,9 @@
             <a:pPr marL="285750" indent="-285750" algn="just">
               <a:buFont typeface="Arial" panose="020B0604020202020204" pitchFamily="34" charset="0"/>
               <a:buChar char="•"/>
+              <a:spcBef>
+                <a:spcPts val="500"/>
+              </a:spcBef>
             </a:pPr>
             <a:r>
               <a:rPr lang="en-US" sz="1400" dirty="0">
@@ -8187,6 +9711,9 @@
             <a:pPr marL="285750" indent="-285750" algn="just">
               <a:buFont typeface="Arial" panose="020B0604020202020204" pitchFamily="34" charset="0"/>
               <a:buChar char="•"/>
+              <a:spcBef>
+                <a:spcPts val="500"/>
+              </a:spcBef>
             </a:pPr>
             <a:r>
               <a:rPr lang="en-US" sz="1400" dirty="0">
@@ -8200,6 +9727,9 @@
             <a:pPr marL="285750" indent="-285750" algn="just">
               <a:buFont typeface="Arial" panose="020B0604020202020204" pitchFamily="34" charset="0"/>
               <a:buChar char="•"/>
+              <a:spcBef>
+                <a:spcPts val="500"/>
+              </a:spcBef>
             </a:pPr>
             <a:r>
               <a:rPr lang="en-US" sz="1400" dirty="0">
@@ -8213,6 +9743,9 @@
             <a:pPr marL="285750" indent="-285750" algn="just">
               <a:buFont typeface="Arial" panose="020B0604020202020204" pitchFamily="34" charset="0"/>
               <a:buChar char="•"/>
+              <a:spcBef>
+                <a:spcPts val="500"/>
+              </a:spcBef>
             </a:pPr>
             <a:r>
               <a:rPr lang="en-US" sz="1400" dirty="0">
@@ -8226,6 +9759,9 @@
             <a:pPr marL="285750" indent="-285750">
               <a:buFont typeface="Wingdings" panose="05000000000000000000" pitchFamily="2" charset="2"/>
               <a:buChar char="v"/>
+              <a:spcBef>
+                <a:spcPts val="900"/>
+              </a:spcBef>
             </a:pPr>
             <a:r>
               <a:rPr lang="en-US" sz="1650" b="1" u="sng" dirty="0">
@@ -8242,6 +9778,9 @@
             <a:pPr marL="285750" indent="-285750" algn="just">
               <a:buFont typeface="Arial" panose="020B0604020202020204" pitchFamily="34" charset="0"/>
               <a:buChar char="•"/>
+              <a:spcBef>
+                <a:spcPts val="500"/>
+              </a:spcBef>
             </a:pPr>
             <a:r>
               <a:rPr lang="en-US" sz="1400" dirty="0">
@@ -8255,39 +9794,32 @@
             <a:pPr marL="285750" indent="-285750" algn="just">
               <a:buFont typeface="Arial" panose="020B0604020202020204" pitchFamily="34" charset="0"/>
               <a:buChar char="•"/>
+              <a:spcBef>
+                <a:spcPts val="500"/>
+              </a:spcBef>
             </a:pPr>
             <a:r>
               <a:rPr lang="en-US" sz="1400" dirty="0">
                 <a:latin typeface="Arial" panose="020B0604020202020204" pitchFamily="34" charset="0"/>
                 <a:cs typeface="Arial" panose="020B0604020202020204" pitchFamily="34" charset="0"/>
               </a:rPr>
-              <a:t>ILO / IMF / OECD / UNECE / World Bank — Consumer Price Index Manual: Concepts and Methods (Jevons, Lowe, hedonic adjustment, chain-linking)</a:t>
+              <a:t>ILO / IMF / OECD / UNECE / World Bank — Consumer Price Index Manual: Concepts and Methods</a:t>
             </a:r>
           </a:p>
           <a:p>
             <a:pPr marL="285750" indent="-285750" algn="just">
               <a:buFont typeface="Arial" panose="020B0604020202020204" pitchFamily="34" charset="0"/>
               <a:buChar char="•"/>
+              <a:spcBef>
+                <a:spcPts val="500"/>
+              </a:spcBef>
             </a:pPr>
             <a:r>
               <a:rPr lang="en-US" sz="1400" dirty="0">
                 <a:latin typeface="Arial" panose="020B0604020202020204" pitchFamily="34" charset="0"/>
                 <a:cs typeface="Arial" panose="020B0604020202020204" pitchFamily="34" charset="0"/>
               </a:rPr>
-              <a:t>RFC 9309 — Robots Exclusion Protocol</a:t>
-            </a:r>
-          </a:p>
-          <a:p>
-            <a:pPr marL="285750" indent="-285750" algn="just">
-              <a:buFont typeface="Arial" panose="020B0604020202020204" pitchFamily="34" charset="0"/>
-              <a:buChar char="•"/>
-            </a:pPr>
-            <a:r>
-              <a:rPr lang="en-US" sz="1400" dirty="0">
-                <a:latin typeface="Arial" panose="020B0604020202020204" pitchFamily="34" charset="0"/>
-                <a:cs typeface="Arial" panose="020B0604020202020204" pitchFamily="34" charset="0"/>
-              </a:rPr>
-              <a:t>Project repository, methodology config and full research record — github.com/Naveen-Boddepalli/aerodex</a:t>
+              <a:t>RFC 9309 — Robots Exclusion Protocol · Repository and research record — github.com/Naveen-Boddepalli/aerodex</a:t>
             </a:r>
           </a:p>
         </p:txBody>
@@ -8413,7 +9945,7 @@
               <a:defRPr/>
             </a:pPr>
             <a:r>
-              <a:rPr kumimoji="0" lang="en-US" sz="1200" b="0" i="0" u="none" strike="noStrike" kern="1200" cap="none" spc="0" normalizeH="0" baseline="0" noProof="0" dirty="0">
+              <a:rPr kumimoji="0" lang="en-US" sz="1200" b="0" i="0" u="none" strike="noStrike" kern="1200" cap="none" spc="0" normalizeH="0" baseline="0" noProof="0">
                 <a:ln>
                   <a:noFill/>
                 </a:ln>
@@ -8427,8 +9959,22 @@
                 <a:ea typeface="+mn-ea"/>
                 <a:cs typeface="+mn-cs"/>
               </a:rPr>
-              <a:t>@SIH Idea submission</a:t>
-            </a:r>
+              <a:t>@SIH Idea submission- Template</a:t>
+            </a:r>
+            <a:endParaRPr kumimoji="0" lang="en-US" sz="1200" b="0" i="0" u="none" strike="noStrike" kern="1200" cap="none" spc="0" normalizeH="0" baseline="0" noProof="0" dirty="0">
+              <a:ln>
+                <a:noFill/>
+              </a:ln>
+              <a:solidFill>
+                <a:prstClr val="white"/>
+              </a:solidFill>
+              <a:effectLst/>
+              <a:uLnTx/>
+              <a:uFillTx/>
+              <a:latin typeface="TradeGothic"/>
+              <a:ea typeface="+mn-ea"/>
+              <a:cs typeface="+mn-cs"/>
+            </a:endParaRPr>
           </a:p>
         </p:txBody>
       </p:sp>
@@ -8440,7 +9986,7 @@
                 <a16:creationId xmlns:a16="http://schemas.microsoft.com/office/drawing/2014/main" id="{5DBCE864-823D-4A13-9607-5DA1F0ED5FB8}"/>
               </a:ext>
               <a:ext uri="{C183D7F6-B498-43B3-948B-1728B52AA6E4}">
-                <adec:decorative xmlns:adec="http://schemas.microsoft.com/office/drawing/2017/decorative" val="0"/>
+                <adec:decorative xmlns:adec="http://schemas.microsoft.com/office/drawing/2017/decorative" xmlns="" val="0"/>
               </a:ext>
             </a:extLst>
           </p:cNvPr>
@@ -8476,10 +10022,10 @@
           <a:p>
             <a:pPr algn="ctr"/>
             <a:r>
-              <a:rPr lang="en-US" sz="1600" dirty="0"/>
-              <a:t>Copilots</a:t>
-            </a:r>
-            <a:endParaRPr lang="en-IN" sz="1600" dirty="0"/>
+              <a:rPr lang="en-US" sz="1000" dirty="0"/>
+              <a:t>[TEAM NAME]</a:t>
+            </a:r>
+            <a:endParaRPr lang="en-IN" dirty="0"/>
           </a:p>
         </p:txBody>
       </p:sp>
@@ -8513,6 +10059,221 @@
           </a:prstGeom>
         </p:spPr>
       </p:pic>
+      <p:sp>
+        <p:nvSpPr>
+          <p:cNvPr id="933" name="homePlate933"/>
+          <p:cNvSpPr/>
+          <p:nvPr/>
+        </p:nvSpPr>
+        <p:spPr>
+          <a:xfrm>
+            <a:off x="475488" y="5431536"/>
+            <a:ext cx="2395728" cy="585216"/>
+          </a:xfrm>
+          <a:prstGeom prst="homePlate">
+            <a:avLst>
+              <a:gd name="adj" fmla="val 18000"/>
+            </a:avLst>
+          </a:prstGeom>
+          <a:solidFill>
+            <a:srgbClr val="4F81BD"/>
+          </a:solidFill>
+          <a:ln>
+            <a:noFill/>
+          </a:ln>
+        </p:spPr>
+        <p:txBody>
+          <a:bodyPr lIns="201168" rIns="201168" tIns="18000" bIns="18000" anchor="ctr" wrap="square">
+            <a:normAutofit/>
+          </a:bodyPr>
+          <a:lstStyle/>
+          <a:p>
+            <a:pPr algn="ctr"/>
+            <a:r>
+              <a:rPr lang="en-US" sz="900" b="1" dirty="0">
+                <a:solidFill>
+                  <a:srgbClr val="FFFFFF"/>
+                </a:solidFill>
+                <a:latin typeface="Arial" panose="020B0604020202020204" pitchFamily="34" charset="0"/>
+                <a:cs typeface="Arial" panose="020B0604020202020204" pitchFamily="34" charset="0"/>
+              </a:rPr>
+              <a:t>4  research passes</a:t>
+            </a:r>
+          </a:p>
+        </p:txBody>
+      </p:sp>
+      <p:sp>
+        <p:nvSpPr>
+          <p:cNvPr id="934" name="homePlate934"/>
+          <p:cNvSpPr/>
+          <p:nvPr/>
+        </p:nvSpPr>
+        <p:spPr>
+          <a:xfrm>
+            <a:off x="2715768" y="5431536"/>
+            <a:ext cx="2395728" cy="585216"/>
+          </a:xfrm>
+          <a:prstGeom prst="homePlate">
+            <a:avLst>
+              <a:gd name="adj" fmla="val 18000"/>
+            </a:avLst>
+          </a:prstGeom>
+          <a:solidFill>
+            <a:srgbClr val="1F497D"/>
+          </a:solidFill>
+          <a:ln>
+            <a:noFill/>
+          </a:ln>
+        </p:spPr>
+        <p:txBody>
+          <a:bodyPr lIns="201168" rIns="201168" tIns="18000" bIns="18000" anchor="ctr" wrap="square">
+            <a:normAutofit/>
+          </a:bodyPr>
+          <a:lstStyle/>
+          <a:p>
+            <a:pPr algn="ctr"/>
+            <a:r>
+              <a:rPr lang="en-US" sz="900" b="1" dirty="0">
+                <a:solidFill>
+                  <a:srgbClr val="FFFFFF"/>
+                </a:solidFill>
+                <a:latin typeface="Arial" panose="020B0604020202020204" pitchFamily="34" charset="0"/>
+                <a:cs typeface="Arial" panose="020B0604020202020204" pitchFamily="34" charset="0"/>
+              </a:rPr>
+              <a:t>40+  sources assessed</a:t>
+            </a:r>
+          </a:p>
+        </p:txBody>
+      </p:sp>
+      <p:sp>
+        <p:nvSpPr>
+          <p:cNvPr id="935" name="homePlate935"/>
+          <p:cNvSpPr/>
+          <p:nvPr/>
+        </p:nvSpPr>
+        <p:spPr>
+          <a:xfrm>
+            <a:off x="4956048" y="5431536"/>
+            <a:ext cx="2395728" cy="585216"/>
+          </a:xfrm>
+          <a:prstGeom prst="homePlate">
+            <a:avLst>
+              <a:gd name="adj" fmla="val 18000"/>
+            </a:avLst>
+          </a:prstGeom>
+          <a:solidFill>
+            <a:srgbClr val="4F81BD"/>
+          </a:solidFill>
+          <a:ln>
+            <a:noFill/>
+          </a:ln>
+        </p:spPr>
+        <p:txBody>
+          <a:bodyPr lIns="201168" rIns="201168" tIns="18000" bIns="18000" anchor="ctr" wrap="square">
+            <a:normAutofit/>
+          </a:bodyPr>
+          <a:lstStyle/>
+          <a:p>
+            <a:pPr algn="ctr"/>
+            <a:r>
+              <a:rPr lang="en-US" sz="900" b="1" dirty="0">
+                <a:solidFill>
+                  <a:srgbClr val="FFFFFF"/>
+                </a:solidFill>
+                <a:latin typeface="Arial" panose="020B0604020202020204" pitchFamily="34" charset="0"/>
+                <a:cs typeface="Arial" panose="020B0604020202020204" pitchFamily="34" charset="0"/>
+              </a:rPr>
+              <a:t>9  axes per source</a:t>
+            </a:r>
+          </a:p>
+        </p:txBody>
+      </p:sp>
+      <p:sp>
+        <p:nvSpPr>
+          <p:cNvPr id="936" name="homePlate936"/>
+          <p:cNvSpPr/>
+          <p:nvPr/>
+        </p:nvSpPr>
+        <p:spPr>
+          <a:xfrm>
+            <a:off x="7196328" y="5431536"/>
+            <a:ext cx="2395728" cy="585216"/>
+          </a:xfrm>
+          <a:prstGeom prst="homePlate">
+            <a:avLst>
+              <a:gd name="adj" fmla="val 18000"/>
+            </a:avLst>
+          </a:prstGeom>
+          <a:solidFill>
+            <a:srgbClr val="1F497D"/>
+          </a:solidFill>
+          <a:ln>
+            <a:noFill/>
+          </a:ln>
+        </p:spPr>
+        <p:txBody>
+          <a:bodyPr lIns="201168" rIns="201168" tIns="18000" bIns="18000" anchor="ctr" wrap="square">
+            <a:normAutofit/>
+          </a:bodyPr>
+          <a:lstStyle/>
+          <a:p>
+            <a:pPr algn="ctr"/>
+            <a:r>
+              <a:rPr lang="en-US" sz="900" b="1" dirty="0">
+                <a:solidFill>
+                  <a:srgbClr val="FFFFFF"/>
+                </a:solidFill>
+                <a:latin typeface="Arial" panose="020B0604020202020204" pitchFamily="34" charset="0"/>
+                <a:cs typeface="Arial" panose="020B0604020202020204" pitchFamily="34" charset="0"/>
+              </a:rPr>
+              <a:t>38  claims registered</a:t>
+            </a:r>
+          </a:p>
+        </p:txBody>
+      </p:sp>
+      <p:sp>
+        <p:nvSpPr>
+          <p:cNvPr id="937" name="homePlate937"/>
+          <p:cNvSpPr/>
+          <p:nvPr/>
+        </p:nvSpPr>
+        <p:spPr>
+          <a:xfrm>
+            <a:off x="9436608" y="5431536"/>
+            <a:ext cx="2395728" cy="585216"/>
+          </a:xfrm>
+          <a:prstGeom prst="homePlate">
+            <a:avLst>
+              <a:gd name="adj" fmla="val 18000"/>
+            </a:avLst>
+          </a:prstGeom>
+          <a:solidFill>
+            <a:srgbClr val="4F81BD"/>
+          </a:solidFill>
+          <a:ln>
+            <a:noFill/>
+          </a:ln>
+        </p:spPr>
+        <p:txBody>
+          <a:bodyPr lIns="201168" rIns="201168" tIns="18000" bIns="18000" anchor="ctr" wrap="square">
+            <a:normAutofit/>
+          </a:bodyPr>
+          <a:lstStyle/>
+          <a:p>
+            <a:pPr algn="ctr"/>
+            <a:r>
+              <a:rPr lang="en-US" sz="900" b="1" dirty="0">
+                <a:solidFill>
+                  <a:srgbClr val="FFFFFF"/>
+                </a:solidFill>
+                <a:latin typeface="Arial" panose="020B0604020202020204" pitchFamily="34" charset="0"/>
+                <a:cs typeface="Arial" panose="020B0604020202020204" pitchFamily="34" charset="0"/>
+              </a:rPr>
+              <a:t>14  tariff sheets parsed</a:t>
+            </a:r>
+          </a:p>
+        </p:txBody>
+      </p:sp>
     </p:spTree>
     <p:extLst>
       <p:ext uri="{BB962C8B-B14F-4D97-AF65-F5344CB8AC3E}">

</xml_diff>